<commit_message>
Add timing diagrams for 5 bit clock
</commit_message>
<xml_diff>
--- a/CPU Design/L1IsDrawings.pptx
+++ b/CPU Design/L1IsDrawings.pptx
@@ -8,6 +8,8 @@
     <p:sldId id="256" r:id="rId2"/>
     <p:sldId id="258" r:id="rId3"/>
     <p:sldId id="259" r:id="rId4"/>
+    <p:sldId id="260" r:id="rId5"/>
+    <p:sldId id="261" r:id="rId6"/>
   </p:sldIdLst>
   <p:sldSz cx="9144000" cy="6858000" type="screen4x3"/>
   <p:notesSz cx="6858000" cy="9144000"/>
@@ -291,7 +293,7 @@
             <a:fld id="{1D8BD707-D9CF-40AE-B4C6-C98DA3205C09}" type="datetimeFigureOut">
               <a:rPr lang="en-US" smtClean="0"/>
               <a:pPr/>
-              <a:t>6/30/2026</a:t>
+              <a:t>7/2/2026</a:t>
             </a:fld>
             <a:endParaRPr lang="en-US"/>
           </a:p>
@@ -458,7 +460,7 @@
             <a:fld id="{1D8BD707-D9CF-40AE-B4C6-C98DA3205C09}" type="datetimeFigureOut">
               <a:rPr lang="en-US" smtClean="0"/>
               <a:pPr/>
-              <a:t>6/30/2026</a:t>
+              <a:t>7/2/2026</a:t>
             </a:fld>
             <a:endParaRPr lang="en-US"/>
           </a:p>
@@ -635,7 +637,7 @@
             <a:fld id="{1D8BD707-D9CF-40AE-B4C6-C98DA3205C09}" type="datetimeFigureOut">
               <a:rPr lang="en-US" smtClean="0"/>
               <a:pPr/>
-              <a:t>6/30/2026</a:t>
+              <a:t>7/2/2026</a:t>
             </a:fld>
             <a:endParaRPr lang="en-US"/>
           </a:p>
@@ -802,7 +804,7 @@
             <a:fld id="{1D8BD707-D9CF-40AE-B4C6-C98DA3205C09}" type="datetimeFigureOut">
               <a:rPr lang="en-US" smtClean="0"/>
               <a:pPr/>
-              <a:t>6/30/2026</a:t>
+              <a:t>7/2/2026</a:t>
             </a:fld>
             <a:endParaRPr lang="en-US"/>
           </a:p>
@@ -1045,7 +1047,7 @@
             <a:fld id="{1D8BD707-D9CF-40AE-B4C6-C98DA3205C09}" type="datetimeFigureOut">
               <a:rPr lang="en-US" smtClean="0"/>
               <a:pPr/>
-              <a:t>6/30/2026</a:t>
+              <a:t>7/2/2026</a:t>
             </a:fld>
             <a:endParaRPr lang="en-US"/>
           </a:p>
@@ -1330,7 +1332,7 @@
             <a:fld id="{1D8BD707-D9CF-40AE-B4C6-C98DA3205C09}" type="datetimeFigureOut">
               <a:rPr lang="en-US" smtClean="0"/>
               <a:pPr/>
-              <a:t>6/30/2026</a:t>
+              <a:t>7/2/2026</a:t>
             </a:fld>
             <a:endParaRPr lang="en-US"/>
           </a:p>
@@ -1749,7 +1751,7 @@
             <a:fld id="{1D8BD707-D9CF-40AE-B4C6-C98DA3205C09}" type="datetimeFigureOut">
               <a:rPr lang="en-US" smtClean="0"/>
               <a:pPr/>
-              <a:t>6/30/2026</a:t>
+              <a:t>7/2/2026</a:t>
             </a:fld>
             <a:endParaRPr lang="en-US"/>
           </a:p>
@@ -1864,7 +1866,7 @@
             <a:fld id="{1D8BD707-D9CF-40AE-B4C6-C98DA3205C09}" type="datetimeFigureOut">
               <a:rPr lang="en-US" smtClean="0"/>
               <a:pPr/>
-              <a:t>6/30/2026</a:t>
+              <a:t>7/2/2026</a:t>
             </a:fld>
             <a:endParaRPr lang="en-US"/>
           </a:p>
@@ -1956,7 +1958,7 @@
             <a:fld id="{1D8BD707-D9CF-40AE-B4C6-C98DA3205C09}" type="datetimeFigureOut">
               <a:rPr lang="en-US" smtClean="0"/>
               <a:pPr/>
-              <a:t>6/30/2026</a:t>
+              <a:t>7/2/2026</a:t>
             </a:fld>
             <a:endParaRPr lang="en-US"/>
           </a:p>
@@ -2230,7 +2232,7 @@
             <a:fld id="{1D8BD707-D9CF-40AE-B4C6-C98DA3205C09}" type="datetimeFigureOut">
               <a:rPr lang="en-US" smtClean="0"/>
               <a:pPr/>
-              <a:t>6/30/2026</a:t>
+              <a:t>7/2/2026</a:t>
             </a:fld>
             <a:endParaRPr lang="en-US"/>
           </a:p>
@@ -2480,7 +2482,7 @@
             <a:fld id="{1D8BD707-D9CF-40AE-B4C6-C98DA3205C09}" type="datetimeFigureOut">
               <a:rPr lang="en-US" smtClean="0"/>
               <a:pPr/>
-              <a:t>6/30/2026</a:t>
+              <a:t>7/2/2026</a:t>
             </a:fld>
             <a:endParaRPr lang="en-US"/>
           </a:p>
@@ -2690,7 +2692,7 @@
             <a:fld id="{1D8BD707-D9CF-40AE-B4C6-C98DA3205C09}" type="datetimeFigureOut">
               <a:rPr lang="en-US" smtClean="0"/>
               <a:pPr/>
-              <a:t>6/30/2026</a:t>
+              <a:t>7/2/2026</a:t>
             </a:fld>
             <a:endParaRPr lang="en-US"/>
           </a:p>
@@ -3579,6 +3581,36 @@
           </a:p>
         </p:txBody>
       </p:sp>
+      <p:sp>
+        <p:nvSpPr>
+          <p:cNvPr id="15" name="TextBox 14"/>
+          <p:cNvSpPr txBox="1"/>
+          <p:nvPr/>
+        </p:nvSpPr>
+        <p:spPr>
+          <a:xfrm>
+            <a:off x="3851771" y="381000"/>
+            <a:ext cx="1440459" cy="369332"/>
+          </a:xfrm>
+          <a:prstGeom prst="rect">
+            <a:avLst/>
+          </a:prstGeom>
+          <a:noFill/>
+        </p:spPr>
+        <p:txBody>
+          <a:bodyPr wrap="none" rtlCol="0">
+            <a:spAutoFit/>
+          </a:bodyPr>
+          <a:lstStyle/>
+          <a:p>
+            <a:r>
+              <a:rPr lang="en-GB" dirty="0" smtClean="0"/>
+              <a:t>ROM LAYOUT</a:t>
+            </a:r>
+            <a:endParaRPr lang="en-GB" dirty="0"/>
+          </a:p>
+        </p:txBody>
+      </p:sp>
     </p:spTree>
   </p:cSld>
   <p:clrMapOvr>
@@ -5256,6 +5288,3557 @@
           </a:p>
         </p:txBody>
       </p:sp>
+      <p:sp>
+        <p:nvSpPr>
+          <p:cNvPr id="55" name="TextBox 54"/>
+          <p:cNvSpPr txBox="1"/>
+          <p:nvPr/>
+        </p:nvSpPr>
+        <p:spPr>
+          <a:xfrm>
+            <a:off x="3126412" y="304800"/>
+            <a:ext cx="2891176" cy="369332"/>
+          </a:xfrm>
+          <a:prstGeom prst="rect">
+            <a:avLst/>
+          </a:prstGeom>
+          <a:noFill/>
+        </p:spPr>
+        <p:txBody>
+          <a:bodyPr wrap="none" rtlCol="0">
+            <a:spAutoFit/>
+          </a:bodyPr>
+          <a:lstStyle/>
+          <a:p>
+            <a:r>
+              <a:rPr lang="en-GB" dirty="0" smtClean="0"/>
+              <a:t>DATA BUS TRANSFER TIMING</a:t>
+            </a:r>
+            <a:endParaRPr lang="en-GB" dirty="0"/>
+          </a:p>
+        </p:txBody>
+      </p:sp>
+    </p:spTree>
+  </p:cSld>
+  <p:clrMapOvr>
+    <a:masterClrMapping/>
+  </p:clrMapOvr>
+</p:sld>
+</file>
+
+<file path=ppt/slides/slide4.xml><?xml version="1.0" encoding="utf-8"?>
+<p:sld xmlns:a="http://schemas.openxmlformats.org/drawingml/2006/main" xmlns:r="http://schemas.openxmlformats.org/officeDocument/2006/relationships" xmlns:p="http://schemas.openxmlformats.org/presentationml/2006/main">
+  <p:cSld>
+    <p:spTree>
+      <p:nvGrpSpPr>
+        <p:cNvPr id="1" name=""/>
+        <p:cNvGrpSpPr/>
+        <p:nvPr/>
+      </p:nvGrpSpPr>
+      <p:grpSpPr>
+        <a:xfrm>
+          <a:off x="0" y="0"/>
+          <a:ext cx="0" cy="0"/>
+          <a:chOff x="0" y="0"/>
+          <a:chExt cx="0" cy="0"/>
+        </a:xfrm>
+      </p:grpSpPr>
+      <p:cxnSp>
+        <p:nvCxnSpPr>
+          <p:cNvPr id="41" name="Straight Connector 40"/>
+          <p:cNvCxnSpPr/>
+          <p:nvPr/>
+        </p:nvCxnSpPr>
+        <p:spPr>
+          <a:xfrm>
+            <a:off x="3935400" y="1295400"/>
+            <a:ext cx="0" cy="3132000"/>
+          </a:xfrm>
+          <a:prstGeom prst="line">
+            <a:avLst/>
+          </a:prstGeom>
+          <a:ln>
+            <a:solidFill>
+              <a:schemeClr val="bg1">
+                <a:lumMod val="75000"/>
+              </a:schemeClr>
+            </a:solidFill>
+            <a:prstDash val="sysDot"/>
+          </a:ln>
+        </p:spPr>
+        <p:style>
+          <a:lnRef idx="1">
+            <a:schemeClr val="accent1"/>
+          </a:lnRef>
+          <a:fillRef idx="0">
+            <a:schemeClr val="accent1"/>
+          </a:fillRef>
+          <a:effectRef idx="0">
+            <a:schemeClr val="accent1"/>
+          </a:effectRef>
+          <a:fontRef idx="minor">
+            <a:schemeClr val="tx1"/>
+          </a:fontRef>
+        </p:style>
+      </p:cxnSp>
+      <p:cxnSp>
+        <p:nvCxnSpPr>
+          <p:cNvPr id="42" name="Straight Connector 41"/>
+          <p:cNvCxnSpPr/>
+          <p:nvPr/>
+        </p:nvCxnSpPr>
+        <p:spPr>
+          <a:xfrm>
+            <a:off x="4655400" y="1295400"/>
+            <a:ext cx="0" cy="3132000"/>
+          </a:xfrm>
+          <a:prstGeom prst="line">
+            <a:avLst/>
+          </a:prstGeom>
+          <a:ln>
+            <a:solidFill>
+              <a:schemeClr val="bg1">
+                <a:lumMod val="75000"/>
+              </a:schemeClr>
+            </a:solidFill>
+            <a:prstDash val="sysDot"/>
+          </a:ln>
+        </p:spPr>
+        <p:style>
+          <a:lnRef idx="1">
+            <a:schemeClr val="accent1"/>
+          </a:lnRef>
+          <a:fillRef idx="0">
+            <a:schemeClr val="accent1"/>
+          </a:fillRef>
+          <a:effectRef idx="0">
+            <a:schemeClr val="accent1"/>
+          </a:effectRef>
+          <a:fontRef idx="minor">
+            <a:schemeClr val="tx1"/>
+          </a:fontRef>
+        </p:style>
+      </p:cxnSp>
+      <p:cxnSp>
+        <p:nvCxnSpPr>
+          <p:cNvPr id="43" name="Straight Connector 42"/>
+          <p:cNvCxnSpPr/>
+          <p:nvPr/>
+        </p:nvCxnSpPr>
+        <p:spPr>
+          <a:xfrm>
+            <a:off x="5375400" y="1295400"/>
+            <a:ext cx="0" cy="3132000"/>
+          </a:xfrm>
+          <a:prstGeom prst="line">
+            <a:avLst/>
+          </a:prstGeom>
+          <a:ln>
+            <a:solidFill>
+              <a:schemeClr val="bg1">
+                <a:lumMod val="75000"/>
+              </a:schemeClr>
+            </a:solidFill>
+            <a:prstDash val="sysDot"/>
+          </a:ln>
+        </p:spPr>
+        <p:style>
+          <a:lnRef idx="1">
+            <a:schemeClr val="accent1"/>
+          </a:lnRef>
+          <a:fillRef idx="0">
+            <a:schemeClr val="accent1"/>
+          </a:fillRef>
+          <a:effectRef idx="0">
+            <a:schemeClr val="accent1"/>
+          </a:effectRef>
+          <a:fontRef idx="minor">
+            <a:schemeClr val="tx1"/>
+          </a:fontRef>
+        </p:style>
+      </p:cxnSp>
+      <p:cxnSp>
+        <p:nvCxnSpPr>
+          <p:cNvPr id="44" name="Straight Connector 43"/>
+          <p:cNvCxnSpPr/>
+          <p:nvPr/>
+        </p:nvCxnSpPr>
+        <p:spPr>
+          <a:xfrm>
+            <a:off x="6095400" y="1295400"/>
+            <a:ext cx="0" cy="3132000"/>
+          </a:xfrm>
+          <a:prstGeom prst="line">
+            <a:avLst/>
+          </a:prstGeom>
+          <a:ln>
+            <a:solidFill>
+              <a:schemeClr val="bg1">
+                <a:lumMod val="75000"/>
+              </a:schemeClr>
+            </a:solidFill>
+            <a:prstDash val="sysDot"/>
+          </a:ln>
+        </p:spPr>
+        <p:style>
+          <a:lnRef idx="1">
+            <a:schemeClr val="accent1"/>
+          </a:lnRef>
+          <a:fillRef idx="0">
+            <a:schemeClr val="accent1"/>
+          </a:fillRef>
+          <a:effectRef idx="0">
+            <a:schemeClr val="accent1"/>
+          </a:effectRef>
+          <a:fontRef idx="minor">
+            <a:schemeClr val="tx1"/>
+          </a:fontRef>
+        </p:style>
+      </p:cxnSp>
+      <p:cxnSp>
+        <p:nvCxnSpPr>
+          <p:cNvPr id="18" name="Straight Connector 17"/>
+          <p:cNvCxnSpPr/>
+          <p:nvPr/>
+        </p:nvCxnSpPr>
+        <p:spPr>
+          <a:xfrm>
+            <a:off x="3935400" y="1600200"/>
+            <a:ext cx="360000" cy="0"/>
+          </a:xfrm>
+          <a:prstGeom prst="line">
+            <a:avLst/>
+          </a:prstGeom>
+        </p:spPr>
+        <p:style>
+          <a:lnRef idx="1">
+            <a:schemeClr val="accent1"/>
+          </a:lnRef>
+          <a:fillRef idx="0">
+            <a:schemeClr val="accent1"/>
+          </a:fillRef>
+          <a:effectRef idx="0">
+            <a:schemeClr val="accent1"/>
+          </a:effectRef>
+          <a:fontRef idx="minor">
+            <a:schemeClr val="tx1"/>
+          </a:fontRef>
+        </p:style>
+      </p:cxnSp>
+      <p:cxnSp>
+        <p:nvCxnSpPr>
+          <p:cNvPr id="21" name="Straight Connector 20"/>
+          <p:cNvCxnSpPr/>
+          <p:nvPr/>
+        </p:nvCxnSpPr>
+        <p:spPr>
+          <a:xfrm>
+            <a:off x="3935400" y="1600200"/>
+            <a:ext cx="0" cy="360000"/>
+          </a:xfrm>
+          <a:prstGeom prst="line">
+            <a:avLst/>
+          </a:prstGeom>
+        </p:spPr>
+        <p:style>
+          <a:lnRef idx="1">
+            <a:schemeClr val="accent1"/>
+          </a:lnRef>
+          <a:fillRef idx="0">
+            <a:schemeClr val="accent1"/>
+          </a:fillRef>
+          <a:effectRef idx="0">
+            <a:schemeClr val="accent1"/>
+          </a:effectRef>
+          <a:fontRef idx="minor">
+            <a:schemeClr val="tx1"/>
+          </a:fontRef>
+        </p:style>
+      </p:cxnSp>
+      <p:cxnSp>
+        <p:nvCxnSpPr>
+          <p:cNvPr id="22" name="Straight Connector 21"/>
+          <p:cNvCxnSpPr/>
+          <p:nvPr/>
+        </p:nvCxnSpPr>
+        <p:spPr>
+          <a:xfrm>
+            <a:off x="4295400" y="1600200"/>
+            <a:ext cx="0" cy="360000"/>
+          </a:xfrm>
+          <a:prstGeom prst="line">
+            <a:avLst/>
+          </a:prstGeom>
+        </p:spPr>
+        <p:style>
+          <a:lnRef idx="1">
+            <a:schemeClr val="accent1"/>
+          </a:lnRef>
+          <a:fillRef idx="0">
+            <a:schemeClr val="accent1"/>
+          </a:fillRef>
+          <a:effectRef idx="0">
+            <a:schemeClr val="accent1"/>
+          </a:effectRef>
+          <a:fontRef idx="minor">
+            <a:schemeClr val="tx1"/>
+          </a:fontRef>
+        </p:style>
+      </p:cxnSp>
+      <p:cxnSp>
+        <p:nvCxnSpPr>
+          <p:cNvPr id="23" name="Straight Connector 22"/>
+          <p:cNvCxnSpPr/>
+          <p:nvPr/>
+        </p:nvCxnSpPr>
+        <p:spPr>
+          <a:xfrm>
+            <a:off x="4295400" y="1960200"/>
+            <a:ext cx="360000" cy="0"/>
+          </a:xfrm>
+          <a:prstGeom prst="line">
+            <a:avLst/>
+          </a:prstGeom>
+        </p:spPr>
+        <p:style>
+          <a:lnRef idx="1">
+            <a:schemeClr val="accent1"/>
+          </a:lnRef>
+          <a:fillRef idx="0">
+            <a:schemeClr val="accent1"/>
+          </a:fillRef>
+          <a:effectRef idx="0">
+            <a:schemeClr val="accent1"/>
+          </a:effectRef>
+          <a:fontRef idx="minor">
+            <a:schemeClr val="tx1"/>
+          </a:fontRef>
+        </p:style>
+      </p:cxnSp>
+      <p:cxnSp>
+        <p:nvCxnSpPr>
+          <p:cNvPr id="24" name="Straight Connector 23"/>
+          <p:cNvCxnSpPr/>
+          <p:nvPr/>
+        </p:nvCxnSpPr>
+        <p:spPr>
+          <a:xfrm>
+            <a:off x="4655400" y="1600200"/>
+            <a:ext cx="360000" cy="0"/>
+          </a:xfrm>
+          <a:prstGeom prst="line">
+            <a:avLst/>
+          </a:prstGeom>
+        </p:spPr>
+        <p:style>
+          <a:lnRef idx="1">
+            <a:schemeClr val="accent1"/>
+          </a:lnRef>
+          <a:fillRef idx="0">
+            <a:schemeClr val="accent1"/>
+          </a:fillRef>
+          <a:effectRef idx="0">
+            <a:schemeClr val="accent1"/>
+          </a:effectRef>
+          <a:fontRef idx="minor">
+            <a:schemeClr val="tx1"/>
+          </a:fontRef>
+        </p:style>
+      </p:cxnSp>
+      <p:cxnSp>
+        <p:nvCxnSpPr>
+          <p:cNvPr id="25" name="Straight Connector 24"/>
+          <p:cNvCxnSpPr/>
+          <p:nvPr/>
+        </p:nvCxnSpPr>
+        <p:spPr>
+          <a:xfrm>
+            <a:off x="4655400" y="1600200"/>
+            <a:ext cx="0" cy="360000"/>
+          </a:xfrm>
+          <a:prstGeom prst="line">
+            <a:avLst/>
+          </a:prstGeom>
+        </p:spPr>
+        <p:style>
+          <a:lnRef idx="1">
+            <a:schemeClr val="accent1"/>
+          </a:lnRef>
+          <a:fillRef idx="0">
+            <a:schemeClr val="accent1"/>
+          </a:fillRef>
+          <a:effectRef idx="0">
+            <a:schemeClr val="accent1"/>
+          </a:effectRef>
+          <a:fontRef idx="minor">
+            <a:schemeClr val="tx1"/>
+          </a:fontRef>
+        </p:style>
+      </p:cxnSp>
+      <p:cxnSp>
+        <p:nvCxnSpPr>
+          <p:cNvPr id="26" name="Straight Connector 25"/>
+          <p:cNvCxnSpPr/>
+          <p:nvPr/>
+        </p:nvCxnSpPr>
+        <p:spPr>
+          <a:xfrm>
+            <a:off x="5015400" y="1600200"/>
+            <a:ext cx="0" cy="360000"/>
+          </a:xfrm>
+          <a:prstGeom prst="line">
+            <a:avLst/>
+          </a:prstGeom>
+        </p:spPr>
+        <p:style>
+          <a:lnRef idx="1">
+            <a:schemeClr val="accent1"/>
+          </a:lnRef>
+          <a:fillRef idx="0">
+            <a:schemeClr val="accent1"/>
+          </a:fillRef>
+          <a:effectRef idx="0">
+            <a:schemeClr val="accent1"/>
+          </a:effectRef>
+          <a:fontRef idx="minor">
+            <a:schemeClr val="tx1"/>
+          </a:fontRef>
+        </p:style>
+      </p:cxnSp>
+      <p:cxnSp>
+        <p:nvCxnSpPr>
+          <p:cNvPr id="27" name="Straight Connector 26"/>
+          <p:cNvCxnSpPr/>
+          <p:nvPr/>
+        </p:nvCxnSpPr>
+        <p:spPr>
+          <a:xfrm>
+            <a:off x="5015400" y="1960200"/>
+            <a:ext cx="360000" cy="0"/>
+          </a:xfrm>
+          <a:prstGeom prst="line">
+            <a:avLst/>
+          </a:prstGeom>
+        </p:spPr>
+        <p:style>
+          <a:lnRef idx="1">
+            <a:schemeClr val="accent1"/>
+          </a:lnRef>
+          <a:fillRef idx="0">
+            <a:schemeClr val="accent1"/>
+          </a:fillRef>
+          <a:effectRef idx="0">
+            <a:schemeClr val="accent1"/>
+          </a:effectRef>
+          <a:fontRef idx="minor">
+            <a:schemeClr val="tx1"/>
+          </a:fontRef>
+        </p:style>
+      </p:cxnSp>
+      <p:cxnSp>
+        <p:nvCxnSpPr>
+          <p:cNvPr id="28" name="Straight Connector 27"/>
+          <p:cNvCxnSpPr/>
+          <p:nvPr/>
+        </p:nvCxnSpPr>
+        <p:spPr>
+          <a:xfrm>
+            <a:off x="5375400" y="1600200"/>
+            <a:ext cx="360000" cy="0"/>
+          </a:xfrm>
+          <a:prstGeom prst="line">
+            <a:avLst/>
+          </a:prstGeom>
+        </p:spPr>
+        <p:style>
+          <a:lnRef idx="1">
+            <a:schemeClr val="accent1"/>
+          </a:lnRef>
+          <a:fillRef idx="0">
+            <a:schemeClr val="accent1"/>
+          </a:fillRef>
+          <a:effectRef idx="0">
+            <a:schemeClr val="accent1"/>
+          </a:effectRef>
+          <a:fontRef idx="minor">
+            <a:schemeClr val="tx1"/>
+          </a:fontRef>
+        </p:style>
+      </p:cxnSp>
+      <p:cxnSp>
+        <p:nvCxnSpPr>
+          <p:cNvPr id="29" name="Straight Connector 28"/>
+          <p:cNvCxnSpPr/>
+          <p:nvPr/>
+        </p:nvCxnSpPr>
+        <p:spPr>
+          <a:xfrm>
+            <a:off x="5375400" y="1600200"/>
+            <a:ext cx="0" cy="360000"/>
+          </a:xfrm>
+          <a:prstGeom prst="line">
+            <a:avLst/>
+          </a:prstGeom>
+        </p:spPr>
+        <p:style>
+          <a:lnRef idx="1">
+            <a:schemeClr val="accent1"/>
+          </a:lnRef>
+          <a:fillRef idx="0">
+            <a:schemeClr val="accent1"/>
+          </a:fillRef>
+          <a:effectRef idx="0">
+            <a:schemeClr val="accent1"/>
+          </a:effectRef>
+          <a:fontRef idx="minor">
+            <a:schemeClr val="tx1"/>
+          </a:fontRef>
+        </p:style>
+      </p:cxnSp>
+      <p:cxnSp>
+        <p:nvCxnSpPr>
+          <p:cNvPr id="30" name="Straight Connector 29"/>
+          <p:cNvCxnSpPr/>
+          <p:nvPr/>
+        </p:nvCxnSpPr>
+        <p:spPr>
+          <a:xfrm>
+            <a:off x="5735400" y="1600200"/>
+            <a:ext cx="0" cy="360000"/>
+          </a:xfrm>
+          <a:prstGeom prst="line">
+            <a:avLst/>
+          </a:prstGeom>
+        </p:spPr>
+        <p:style>
+          <a:lnRef idx="1">
+            <a:schemeClr val="accent1"/>
+          </a:lnRef>
+          <a:fillRef idx="0">
+            <a:schemeClr val="accent1"/>
+          </a:fillRef>
+          <a:effectRef idx="0">
+            <a:schemeClr val="accent1"/>
+          </a:effectRef>
+          <a:fontRef idx="minor">
+            <a:schemeClr val="tx1"/>
+          </a:fontRef>
+        </p:style>
+      </p:cxnSp>
+      <p:cxnSp>
+        <p:nvCxnSpPr>
+          <p:cNvPr id="31" name="Straight Connector 30"/>
+          <p:cNvCxnSpPr/>
+          <p:nvPr/>
+        </p:nvCxnSpPr>
+        <p:spPr>
+          <a:xfrm>
+            <a:off x="5735400" y="1960200"/>
+            <a:ext cx="360000" cy="0"/>
+          </a:xfrm>
+          <a:prstGeom prst="line">
+            <a:avLst/>
+          </a:prstGeom>
+        </p:spPr>
+        <p:style>
+          <a:lnRef idx="1">
+            <a:schemeClr val="accent1"/>
+          </a:lnRef>
+          <a:fillRef idx="0">
+            <a:schemeClr val="accent1"/>
+          </a:fillRef>
+          <a:effectRef idx="0">
+            <a:schemeClr val="accent1"/>
+          </a:effectRef>
+          <a:fontRef idx="minor">
+            <a:schemeClr val="tx1"/>
+          </a:fontRef>
+        </p:style>
+      </p:cxnSp>
+      <p:cxnSp>
+        <p:nvCxnSpPr>
+          <p:cNvPr id="33" name="Straight Connector 32"/>
+          <p:cNvCxnSpPr/>
+          <p:nvPr/>
+        </p:nvCxnSpPr>
+        <p:spPr>
+          <a:xfrm>
+            <a:off x="6095400" y="1600200"/>
+            <a:ext cx="0" cy="360000"/>
+          </a:xfrm>
+          <a:prstGeom prst="line">
+            <a:avLst/>
+          </a:prstGeom>
+        </p:spPr>
+        <p:style>
+          <a:lnRef idx="1">
+            <a:schemeClr val="accent1"/>
+          </a:lnRef>
+          <a:fillRef idx="0">
+            <a:schemeClr val="accent1"/>
+          </a:fillRef>
+          <a:effectRef idx="0">
+            <a:schemeClr val="accent1"/>
+          </a:effectRef>
+          <a:fontRef idx="minor">
+            <a:schemeClr val="tx1"/>
+          </a:fontRef>
+        </p:style>
+      </p:cxnSp>
+      <p:sp>
+        <p:nvSpPr>
+          <p:cNvPr id="46" name="TextBox 45"/>
+          <p:cNvSpPr txBox="1"/>
+          <p:nvPr/>
+        </p:nvSpPr>
+        <p:spPr>
+          <a:xfrm>
+            <a:off x="2539795" y="1615440"/>
+            <a:ext cx="728405" cy="338554"/>
+          </a:xfrm>
+          <a:prstGeom prst="rect">
+            <a:avLst/>
+          </a:prstGeom>
+          <a:noFill/>
+        </p:spPr>
+        <p:txBody>
+          <a:bodyPr wrap="none" rtlCol="0">
+            <a:spAutoFit/>
+          </a:bodyPr>
+          <a:lstStyle/>
+          <a:p>
+            <a:r>
+              <a:rPr lang="en-GB" sz="1600" dirty="0" smtClean="0"/>
+              <a:t>CLOCK</a:t>
+            </a:r>
+            <a:endParaRPr lang="en-GB" sz="1600" dirty="0"/>
+          </a:p>
+        </p:txBody>
+      </p:sp>
+      <p:sp>
+        <p:nvSpPr>
+          <p:cNvPr id="54" name="TextBox 53"/>
+          <p:cNvSpPr txBox="1"/>
+          <p:nvPr/>
+        </p:nvSpPr>
+        <p:spPr>
+          <a:xfrm>
+            <a:off x="2290047" y="2164080"/>
+            <a:ext cx="978153" cy="338554"/>
+          </a:xfrm>
+          <a:prstGeom prst="rect">
+            <a:avLst/>
+          </a:prstGeom>
+          <a:noFill/>
+        </p:spPr>
+        <p:txBody>
+          <a:bodyPr wrap="none" rtlCol="0">
+            <a:spAutoFit/>
+          </a:bodyPr>
+          <a:lstStyle/>
+          <a:p>
+            <a:r>
+              <a:rPr lang="en-GB" sz="1600" dirty="0" smtClean="0"/>
+              <a:t>SEQ_END</a:t>
+            </a:r>
+            <a:endParaRPr lang="en-GB" sz="1600" dirty="0"/>
+          </a:p>
+        </p:txBody>
+      </p:sp>
+      <p:cxnSp>
+        <p:nvCxnSpPr>
+          <p:cNvPr id="63" name="Straight Connector 62"/>
+          <p:cNvCxnSpPr/>
+          <p:nvPr/>
+        </p:nvCxnSpPr>
+        <p:spPr>
+          <a:xfrm>
+            <a:off x="3216000" y="2514600"/>
+            <a:ext cx="781200" cy="0"/>
+          </a:xfrm>
+          <a:prstGeom prst="line">
+            <a:avLst/>
+          </a:prstGeom>
+        </p:spPr>
+        <p:style>
+          <a:lnRef idx="1">
+            <a:schemeClr val="accent1"/>
+          </a:lnRef>
+          <a:fillRef idx="0">
+            <a:schemeClr val="accent1"/>
+          </a:fillRef>
+          <a:effectRef idx="0">
+            <a:schemeClr val="accent1"/>
+          </a:effectRef>
+          <a:fontRef idx="minor">
+            <a:schemeClr val="tx1"/>
+          </a:fontRef>
+        </p:style>
+      </p:cxnSp>
+      <p:cxnSp>
+        <p:nvCxnSpPr>
+          <p:cNvPr id="64" name="Straight Connector 63"/>
+          <p:cNvCxnSpPr/>
+          <p:nvPr/>
+        </p:nvCxnSpPr>
+        <p:spPr>
+          <a:xfrm>
+            <a:off x="3996600" y="2154600"/>
+            <a:ext cx="0" cy="360000"/>
+          </a:xfrm>
+          <a:prstGeom prst="line">
+            <a:avLst/>
+          </a:prstGeom>
+        </p:spPr>
+        <p:style>
+          <a:lnRef idx="1">
+            <a:schemeClr val="accent1"/>
+          </a:lnRef>
+          <a:fillRef idx="0">
+            <a:schemeClr val="accent1"/>
+          </a:fillRef>
+          <a:effectRef idx="0">
+            <a:schemeClr val="accent1"/>
+          </a:effectRef>
+          <a:fontRef idx="minor">
+            <a:schemeClr val="tx1"/>
+          </a:fontRef>
+        </p:style>
+      </p:cxnSp>
+      <p:cxnSp>
+        <p:nvCxnSpPr>
+          <p:cNvPr id="65" name="Straight Connector 64"/>
+          <p:cNvCxnSpPr/>
+          <p:nvPr/>
+        </p:nvCxnSpPr>
+        <p:spPr>
+          <a:xfrm>
+            <a:off x="4716600" y="2154600"/>
+            <a:ext cx="0" cy="360000"/>
+          </a:xfrm>
+          <a:prstGeom prst="line">
+            <a:avLst/>
+          </a:prstGeom>
+        </p:spPr>
+        <p:style>
+          <a:lnRef idx="1">
+            <a:schemeClr val="accent1"/>
+          </a:lnRef>
+          <a:fillRef idx="0">
+            <a:schemeClr val="accent1"/>
+          </a:fillRef>
+          <a:effectRef idx="0">
+            <a:schemeClr val="accent1"/>
+          </a:effectRef>
+          <a:fontRef idx="minor">
+            <a:schemeClr val="tx1"/>
+          </a:fontRef>
+        </p:style>
+      </p:cxnSp>
+      <p:cxnSp>
+        <p:nvCxnSpPr>
+          <p:cNvPr id="66" name="Straight Connector 65"/>
+          <p:cNvCxnSpPr/>
+          <p:nvPr/>
+        </p:nvCxnSpPr>
+        <p:spPr>
+          <a:xfrm>
+            <a:off x="3996600" y="2159000"/>
+            <a:ext cx="720000" cy="0"/>
+          </a:xfrm>
+          <a:prstGeom prst="line">
+            <a:avLst/>
+          </a:prstGeom>
+        </p:spPr>
+        <p:style>
+          <a:lnRef idx="1">
+            <a:schemeClr val="accent1"/>
+          </a:lnRef>
+          <a:fillRef idx="0">
+            <a:schemeClr val="accent1"/>
+          </a:fillRef>
+          <a:effectRef idx="0">
+            <a:schemeClr val="accent1"/>
+          </a:effectRef>
+          <a:fontRef idx="minor">
+            <a:schemeClr val="tx1"/>
+          </a:fontRef>
+        </p:style>
+      </p:cxnSp>
+      <p:cxnSp>
+        <p:nvCxnSpPr>
+          <p:cNvPr id="67" name="Straight Connector 66"/>
+          <p:cNvCxnSpPr/>
+          <p:nvPr/>
+        </p:nvCxnSpPr>
+        <p:spPr>
+          <a:xfrm>
+            <a:off x="4716600" y="2514600"/>
+            <a:ext cx="1378800" cy="0"/>
+          </a:xfrm>
+          <a:prstGeom prst="line">
+            <a:avLst/>
+          </a:prstGeom>
+        </p:spPr>
+        <p:style>
+          <a:lnRef idx="1">
+            <a:schemeClr val="accent1"/>
+          </a:lnRef>
+          <a:fillRef idx="0">
+            <a:schemeClr val="accent1"/>
+          </a:fillRef>
+          <a:effectRef idx="0">
+            <a:schemeClr val="accent1"/>
+          </a:effectRef>
+          <a:fontRef idx="minor">
+            <a:schemeClr val="tx1"/>
+          </a:fontRef>
+        </p:style>
+      </p:cxnSp>
+      <p:cxnSp>
+        <p:nvCxnSpPr>
+          <p:cNvPr id="87" name="Straight Arrow Connector 86"/>
+          <p:cNvCxnSpPr/>
+          <p:nvPr/>
+        </p:nvCxnSpPr>
+        <p:spPr>
+          <a:xfrm>
+            <a:off x="3935400" y="1295400"/>
+            <a:ext cx="720000" cy="0"/>
+          </a:xfrm>
+          <a:prstGeom prst="straightConnector1">
+            <a:avLst/>
+          </a:prstGeom>
+          <a:ln>
+            <a:headEnd type="arrow" w="sm" len="sm"/>
+            <a:tailEnd type="arrow" w="sm" len="sm"/>
+          </a:ln>
+        </p:spPr>
+        <p:style>
+          <a:lnRef idx="1">
+            <a:schemeClr val="accent1"/>
+          </a:lnRef>
+          <a:fillRef idx="0">
+            <a:schemeClr val="accent1"/>
+          </a:fillRef>
+          <a:effectRef idx="0">
+            <a:schemeClr val="accent1"/>
+          </a:effectRef>
+          <a:fontRef idx="minor">
+            <a:schemeClr val="tx1"/>
+          </a:fontRef>
+        </p:style>
+      </p:cxnSp>
+      <p:cxnSp>
+        <p:nvCxnSpPr>
+          <p:cNvPr id="88" name="Straight Arrow Connector 87"/>
+          <p:cNvCxnSpPr/>
+          <p:nvPr/>
+        </p:nvCxnSpPr>
+        <p:spPr>
+          <a:xfrm>
+            <a:off x="4655400" y="1295400"/>
+            <a:ext cx="720000" cy="0"/>
+          </a:xfrm>
+          <a:prstGeom prst="straightConnector1">
+            <a:avLst/>
+          </a:prstGeom>
+          <a:ln>
+            <a:headEnd type="arrow" w="sm" len="sm"/>
+            <a:tailEnd type="arrow" w="sm" len="sm"/>
+          </a:ln>
+        </p:spPr>
+        <p:style>
+          <a:lnRef idx="1">
+            <a:schemeClr val="accent1"/>
+          </a:lnRef>
+          <a:fillRef idx="0">
+            <a:schemeClr val="accent1"/>
+          </a:fillRef>
+          <a:effectRef idx="0">
+            <a:schemeClr val="accent1"/>
+          </a:effectRef>
+          <a:fontRef idx="minor">
+            <a:schemeClr val="tx1"/>
+          </a:fontRef>
+        </p:style>
+      </p:cxnSp>
+      <p:cxnSp>
+        <p:nvCxnSpPr>
+          <p:cNvPr id="91" name="Straight Arrow Connector 90"/>
+          <p:cNvCxnSpPr/>
+          <p:nvPr/>
+        </p:nvCxnSpPr>
+        <p:spPr>
+          <a:xfrm>
+            <a:off x="5375400" y="1295400"/>
+            <a:ext cx="720000" cy="0"/>
+          </a:xfrm>
+          <a:prstGeom prst="straightConnector1">
+            <a:avLst/>
+          </a:prstGeom>
+          <a:ln>
+            <a:headEnd type="arrow" w="sm" len="sm"/>
+            <a:tailEnd type="arrow" w="sm" len="sm"/>
+          </a:ln>
+        </p:spPr>
+        <p:style>
+          <a:lnRef idx="1">
+            <a:schemeClr val="accent1"/>
+          </a:lnRef>
+          <a:fillRef idx="0">
+            <a:schemeClr val="accent1"/>
+          </a:fillRef>
+          <a:effectRef idx="0">
+            <a:schemeClr val="accent1"/>
+          </a:effectRef>
+          <a:fontRef idx="minor">
+            <a:schemeClr val="tx1"/>
+          </a:fontRef>
+        </p:style>
+      </p:cxnSp>
+      <p:sp>
+        <p:nvSpPr>
+          <p:cNvPr id="100" name="TextBox 99"/>
+          <p:cNvSpPr txBox="1"/>
+          <p:nvPr/>
+        </p:nvSpPr>
+        <p:spPr>
+          <a:xfrm>
+            <a:off x="4169684" y="990600"/>
+            <a:ext cx="317716" cy="338554"/>
+          </a:xfrm>
+          <a:prstGeom prst="rect">
+            <a:avLst/>
+          </a:prstGeom>
+          <a:noFill/>
+        </p:spPr>
+        <p:txBody>
+          <a:bodyPr wrap="none" rtlCol="0">
+            <a:spAutoFit/>
+          </a:bodyPr>
+          <a:lstStyle/>
+          <a:p>
+            <a:r>
+              <a:rPr lang="en-GB" sz="1600" dirty="0" smtClean="0"/>
+              <a:t>N</a:t>
+            </a:r>
+            <a:endParaRPr lang="en-GB" sz="1600" dirty="0"/>
+          </a:p>
+        </p:txBody>
+      </p:sp>
+      <p:sp>
+        <p:nvSpPr>
+          <p:cNvPr id="101" name="TextBox 100"/>
+          <p:cNvSpPr txBox="1"/>
+          <p:nvPr/>
+        </p:nvSpPr>
+        <p:spPr>
+          <a:xfrm>
+            <a:off x="4909738" y="990600"/>
+            <a:ext cx="288862" cy="338554"/>
+          </a:xfrm>
+          <a:prstGeom prst="rect">
+            <a:avLst/>
+          </a:prstGeom>
+          <a:noFill/>
+        </p:spPr>
+        <p:txBody>
+          <a:bodyPr wrap="none" rtlCol="0">
+            <a:spAutoFit/>
+          </a:bodyPr>
+          <a:lstStyle/>
+          <a:p>
+            <a:r>
+              <a:rPr lang="en-GB" sz="1600" dirty="0" smtClean="0"/>
+              <a:t>0</a:t>
+            </a:r>
+            <a:endParaRPr lang="en-GB" sz="1600" dirty="0"/>
+          </a:p>
+        </p:txBody>
+      </p:sp>
+      <p:sp>
+        <p:nvSpPr>
+          <p:cNvPr id="102" name="TextBox 101"/>
+          <p:cNvSpPr txBox="1"/>
+          <p:nvPr/>
+        </p:nvSpPr>
+        <p:spPr>
+          <a:xfrm>
+            <a:off x="5620938" y="990600"/>
+            <a:ext cx="288862" cy="338554"/>
+          </a:xfrm>
+          <a:prstGeom prst="rect">
+            <a:avLst/>
+          </a:prstGeom>
+          <a:noFill/>
+        </p:spPr>
+        <p:txBody>
+          <a:bodyPr wrap="none" rtlCol="0">
+            <a:spAutoFit/>
+          </a:bodyPr>
+          <a:lstStyle/>
+          <a:p>
+            <a:r>
+              <a:rPr lang="en-GB" sz="1600" dirty="0" smtClean="0"/>
+              <a:t>1</a:t>
+            </a:r>
+            <a:endParaRPr lang="en-GB" sz="1600" dirty="0"/>
+          </a:p>
+        </p:txBody>
+      </p:sp>
+      <p:sp>
+        <p:nvSpPr>
+          <p:cNvPr id="55" name="TextBox 54"/>
+          <p:cNvSpPr txBox="1"/>
+          <p:nvPr/>
+        </p:nvSpPr>
+        <p:spPr>
+          <a:xfrm>
+            <a:off x="2684194" y="1066800"/>
+            <a:ext cx="584006" cy="338554"/>
+          </a:xfrm>
+          <a:prstGeom prst="rect">
+            <a:avLst/>
+          </a:prstGeom>
+          <a:noFill/>
+        </p:spPr>
+        <p:txBody>
+          <a:bodyPr wrap="none" rtlCol="0">
+            <a:spAutoFit/>
+          </a:bodyPr>
+          <a:lstStyle/>
+          <a:p>
+            <a:r>
+              <a:rPr lang="en-GB" sz="1600" dirty="0" smtClean="0"/>
+              <a:t>STEP</a:t>
+            </a:r>
+            <a:endParaRPr lang="en-GB" sz="1600" dirty="0"/>
+          </a:p>
+        </p:txBody>
+      </p:sp>
+      <p:sp>
+        <p:nvSpPr>
+          <p:cNvPr id="68" name="TextBox 67"/>
+          <p:cNvSpPr txBox="1"/>
+          <p:nvPr/>
+        </p:nvSpPr>
+        <p:spPr>
+          <a:xfrm>
+            <a:off x="2472789" y="2712720"/>
+            <a:ext cx="795411" cy="338554"/>
+          </a:xfrm>
+          <a:prstGeom prst="rect">
+            <a:avLst/>
+          </a:prstGeom>
+          <a:noFill/>
+        </p:spPr>
+        <p:txBody>
+          <a:bodyPr wrap="none" rtlCol="0">
+            <a:spAutoFit/>
+          </a:bodyPr>
+          <a:lstStyle/>
+          <a:p>
+            <a:r>
+              <a:rPr lang="en-GB" sz="1600" dirty="0" smtClean="0"/>
+              <a:t>INC_PC</a:t>
+            </a:r>
+          </a:p>
+        </p:txBody>
+      </p:sp>
+      <p:cxnSp>
+        <p:nvCxnSpPr>
+          <p:cNvPr id="69" name="Straight Connector 68"/>
+          <p:cNvCxnSpPr/>
+          <p:nvPr/>
+        </p:nvCxnSpPr>
+        <p:spPr>
+          <a:xfrm>
+            <a:off x="3216000" y="3078000"/>
+            <a:ext cx="781200" cy="0"/>
+          </a:xfrm>
+          <a:prstGeom prst="line">
+            <a:avLst/>
+          </a:prstGeom>
+        </p:spPr>
+        <p:style>
+          <a:lnRef idx="1">
+            <a:schemeClr val="accent1"/>
+          </a:lnRef>
+          <a:fillRef idx="0">
+            <a:schemeClr val="accent1"/>
+          </a:fillRef>
+          <a:effectRef idx="0">
+            <a:schemeClr val="accent1"/>
+          </a:effectRef>
+          <a:fontRef idx="minor">
+            <a:schemeClr val="tx1"/>
+          </a:fontRef>
+        </p:style>
+      </p:cxnSp>
+      <p:cxnSp>
+        <p:nvCxnSpPr>
+          <p:cNvPr id="70" name="Straight Connector 69"/>
+          <p:cNvCxnSpPr/>
+          <p:nvPr/>
+        </p:nvCxnSpPr>
+        <p:spPr>
+          <a:xfrm>
+            <a:off x="3988800" y="2718000"/>
+            <a:ext cx="0" cy="360000"/>
+          </a:xfrm>
+          <a:prstGeom prst="line">
+            <a:avLst/>
+          </a:prstGeom>
+        </p:spPr>
+        <p:style>
+          <a:lnRef idx="1">
+            <a:schemeClr val="accent1"/>
+          </a:lnRef>
+          <a:fillRef idx="0">
+            <a:schemeClr val="accent1"/>
+          </a:fillRef>
+          <a:effectRef idx="0">
+            <a:schemeClr val="accent1"/>
+          </a:effectRef>
+          <a:fontRef idx="minor">
+            <a:schemeClr val="tx1"/>
+          </a:fontRef>
+        </p:style>
+      </p:cxnSp>
+      <p:cxnSp>
+        <p:nvCxnSpPr>
+          <p:cNvPr id="71" name="Straight Connector 70"/>
+          <p:cNvCxnSpPr/>
+          <p:nvPr/>
+        </p:nvCxnSpPr>
+        <p:spPr>
+          <a:xfrm>
+            <a:off x="4708800" y="2718000"/>
+            <a:ext cx="0" cy="360000"/>
+          </a:xfrm>
+          <a:prstGeom prst="line">
+            <a:avLst/>
+          </a:prstGeom>
+        </p:spPr>
+        <p:style>
+          <a:lnRef idx="1">
+            <a:schemeClr val="accent1"/>
+          </a:lnRef>
+          <a:fillRef idx="0">
+            <a:schemeClr val="accent1"/>
+          </a:fillRef>
+          <a:effectRef idx="0">
+            <a:schemeClr val="accent1"/>
+          </a:effectRef>
+          <a:fontRef idx="minor">
+            <a:schemeClr val="tx1"/>
+          </a:fontRef>
+        </p:style>
+      </p:cxnSp>
+      <p:cxnSp>
+        <p:nvCxnSpPr>
+          <p:cNvPr id="72" name="Straight Connector 71"/>
+          <p:cNvCxnSpPr/>
+          <p:nvPr/>
+        </p:nvCxnSpPr>
+        <p:spPr>
+          <a:xfrm>
+            <a:off x="3988800" y="2718000"/>
+            <a:ext cx="720000" cy="0"/>
+          </a:xfrm>
+          <a:prstGeom prst="line">
+            <a:avLst/>
+          </a:prstGeom>
+        </p:spPr>
+        <p:style>
+          <a:lnRef idx="1">
+            <a:schemeClr val="accent1"/>
+          </a:lnRef>
+          <a:fillRef idx="0">
+            <a:schemeClr val="accent1"/>
+          </a:fillRef>
+          <a:effectRef idx="0">
+            <a:schemeClr val="accent1"/>
+          </a:effectRef>
+          <a:fontRef idx="minor">
+            <a:schemeClr val="tx1"/>
+          </a:fontRef>
+        </p:style>
+      </p:cxnSp>
+      <p:cxnSp>
+        <p:nvCxnSpPr>
+          <p:cNvPr id="78" name="Straight Connector 77"/>
+          <p:cNvCxnSpPr/>
+          <p:nvPr/>
+        </p:nvCxnSpPr>
+        <p:spPr>
+          <a:xfrm>
+            <a:off x="4708800" y="3078000"/>
+            <a:ext cx="1378800" cy="0"/>
+          </a:xfrm>
+          <a:prstGeom prst="line">
+            <a:avLst/>
+          </a:prstGeom>
+        </p:spPr>
+        <p:style>
+          <a:lnRef idx="1">
+            <a:schemeClr val="accent1"/>
+          </a:lnRef>
+          <a:fillRef idx="0">
+            <a:schemeClr val="accent1"/>
+          </a:fillRef>
+          <a:effectRef idx="0">
+            <a:schemeClr val="accent1"/>
+          </a:effectRef>
+          <a:fontRef idx="minor">
+            <a:schemeClr val="tx1"/>
+          </a:fontRef>
+        </p:style>
+      </p:cxnSp>
+      <p:cxnSp>
+        <p:nvCxnSpPr>
+          <p:cNvPr id="79" name="Straight Connector 78"/>
+          <p:cNvCxnSpPr/>
+          <p:nvPr/>
+        </p:nvCxnSpPr>
+        <p:spPr>
+          <a:xfrm>
+            <a:off x="3216000" y="1295400"/>
+            <a:ext cx="0" cy="3132000"/>
+          </a:xfrm>
+          <a:prstGeom prst="line">
+            <a:avLst/>
+          </a:prstGeom>
+          <a:ln>
+            <a:solidFill>
+              <a:schemeClr val="bg1">
+                <a:lumMod val="75000"/>
+              </a:schemeClr>
+            </a:solidFill>
+            <a:prstDash val="sysDot"/>
+          </a:ln>
+        </p:spPr>
+        <p:style>
+          <a:lnRef idx="1">
+            <a:schemeClr val="accent1"/>
+          </a:lnRef>
+          <a:fillRef idx="0">
+            <a:schemeClr val="accent1"/>
+          </a:fillRef>
+          <a:effectRef idx="0">
+            <a:schemeClr val="accent1"/>
+          </a:effectRef>
+          <a:fontRef idx="minor">
+            <a:schemeClr val="tx1"/>
+          </a:fontRef>
+        </p:style>
+      </p:cxnSp>
+      <p:cxnSp>
+        <p:nvCxnSpPr>
+          <p:cNvPr id="80" name="Straight Arrow Connector 79"/>
+          <p:cNvCxnSpPr/>
+          <p:nvPr/>
+        </p:nvCxnSpPr>
+        <p:spPr>
+          <a:xfrm>
+            <a:off x="3216000" y="1295400"/>
+            <a:ext cx="720000" cy="0"/>
+          </a:xfrm>
+          <a:prstGeom prst="straightConnector1">
+            <a:avLst/>
+          </a:prstGeom>
+          <a:ln>
+            <a:headEnd type="arrow" w="sm" len="sm"/>
+            <a:tailEnd type="arrow" w="sm" len="sm"/>
+          </a:ln>
+        </p:spPr>
+        <p:style>
+          <a:lnRef idx="1">
+            <a:schemeClr val="accent1"/>
+          </a:lnRef>
+          <a:fillRef idx="0">
+            <a:schemeClr val="accent1"/>
+          </a:fillRef>
+          <a:effectRef idx="0">
+            <a:schemeClr val="accent1"/>
+          </a:effectRef>
+          <a:fontRef idx="minor">
+            <a:schemeClr val="tx1"/>
+          </a:fontRef>
+        </p:style>
+      </p:cxnSp>
+      <p:sp>
+        <p:nvSpPr>
+          <p:cNvPr id="81" name="TextBox 80"/>
+          <p:cNvSpPr txBox="1"/>
+          <p:nvPr/>
+        </p:nvSpPr>
+        <p:spPr>
+          <a:xfrm>
+            <a:off x="3317172" y="990600"/>
+            <a:ext cx="484428" cy="338554"/>
+          </a:xfrm>
+          <a:prstGeom prst="rect">
+            <a:avLst/>
+          </a:prstGeom>
+          <a:noFill/>
+        </p:spPr>
+        <p:txBody>
+          <a:bodyPr wrap="none" rtlCol="0">
+            <a:spAutoFit/>
+          </a:bodyPr>
+          <a:lstStyle/>
+          <a:p>
+            <a:r>
+              <a:rPr lang="en-GB" sz="1600" dirty="0" smtClean="0"/>
+              <a:t>N-1</a:t>
+            </a:r>
+            <a:endParaRPr lang="en-GB" sz="1600" dirty="0"/>
+          </a:p>
+        </p:txBody>
+      </p:sp>
+      <p:cxnSp>
+        <p:nvCxnSpPr>
+          <p:cNvPr id="82" name="Straight Connector 81"/>
+          <p:cNvCxnSpPr/>
+          <p:nvPr/>
+        </p:nvCxnSpPr>
+        <p:spPr>
+          <a:xfrm>
+            <a:off x="3216000" y="1600200"/>
+            <a:ext cx="360000" cy="0"/>
+          </a:xfrm>
+          <a:prstGeom prst="line">
+            <a:avLst/>
+          </a:prstGeom>
+        </p:spPr>
+        <p:style>
+          <a:lnRef idx="1">
+            <a:schemeClr val="accent1"/>
+          </a:lnRef>
+          <a:fillRef idx="0">
+            <a:schemeClr val="accent1"/>
+          </a:fillRef>
+          <a:effectRef idx="0">
+            <a:schemeClr val="accent1"/>
+          </a:effectRef>
+          <a:fontRef idx="minor">
+            <a:schemeClr val="tx1"/>
+          </a:fontRef>
+        </p:style>
+      </p:cxnSp>
+      <p:cxnSp>
+        <p:nvCxnSpPr>
+          <p:cNvPr id="83" name="Straight Connector 82"/>
+          <p:cNvCxnSpPr/>
+          <p:nvPr/>
+        </p:nvCxnSpPr>
+        <p:spPr>
+          <a:xfrm>
+            <a:off x="3216000" y="1600200"/>
+            <a:ext cx="0" cy="360000"/>
+          </a:xfrm>
+          <a:prstGeom prst="line">
+            <a:avLst/>
+          </a:prstGeom>
+        </p:spPr>
+        <p:style>
+          <a:lnRef idx="1">
+            <a:schemeClr val="accent1"/>
+          </a:lnRef>
+          <a:fillRef idx="0">
+            <a:schemeClr val="accent1"/>
+          </a:fillRef>
+          <a:effectRef idx="0">
+            <a:schemeClr val="accent1"/>
+          </a:effectRef>
+          <a:fontRef idx="minor">
+            <a:schemeClr val="tx1"/>
+          </a:fontRef>
+        </p:style>
+      </p:cxnSp>
+      <p:cxnSp>
+        <p:nvCxnSpPr>
+          <p:cNvPr id="84" name="Straight Connector 83"/>
+          <p:cNvCxnSpPr/>
+          <p:nvPr/>
+        </p:nvCxnSpPr>
+        <p:spPr>
+          <a:xfrm>
+            <a:off x="3576000" y="1600200"/>
+            <a:ext cx="0" cy="360000"/>
+          </a:xfrm>
+          <a:prstGeom prst="line">
+            <a:avLst/>
+          </a:prstGeom>
+        </p:spPr>
+        <p:style>
+          <a:lnRef idx="1">
+            <a:schemeClr val="accent1"/>
+          </a:lnRef>
+          <a:fillRef idx="0">
+            <a:schemeClr val="accent1"/>
+          </a:fillRef>
+          <a:effectRef idx="0">
+            <a:schemeClr val="accent1"/>
+          </a:effectRef>
+          <a:fontRef idx="minor">
+            <a:schemeClr val="tx1"/>
+          </a:fontRef>
+        </p:style>
+      </p:cxnSp>
+      <p:cxnSp>
+        <p:nvCxnSpPr>
+          <p:cNvPr id="85" name="Straight Connector 84"/>
+          <p:cNvCxnSpPr/>
+          <p:nvPr/>
+        </p:nvCxnSpPr>
+        <p:spPr>
+          <a:xfrm>
+            <a:off x="3576000" y="1960200"/>
+            <a:ext cx="360000" cy="0"/>
+          </a:xfrm>
+          <a:prstGeom prst="line">
+            <a:avLst/>
+          </a:prstGeom>
+        </p:spPr>
+        <p:style>
+          <a:lnRef idx="1">
+            <a:schemeClr val="accent1"/>
+          </a:lnRef>
+          <a:fillRef idx="0">
+            <a:schemeClr val="accent1"/>
+          </a:fillRef>
+          <a:effectRef idx="0">
+            <a:schemeClr val="accent1"/>
+          </a:effectRef>
+          <a:fontRef idx="minor">
+            <a:schemeClr val="tx1"/>
+          </a:fontRef>
+        </p:style>
+      </p:cxnSp>
+      <p:cxnSp>
+        <p:nvCxnSpPr>
+          <p:cNvPr id="86" name="Straight Connector 85"/>
+          <p:cNvCxnSpPr/>
+          <p:nvPr/>
+        </p:nvCxnSpPr>
+        <p:spPr>
+          <a:xfrm>
+            <a:off x="3216000" y="3636000"/>
+            <a:ext cx="842400" cy="0"/>
+          </a:xfrm>
+          <a:prstGeom prst="line">
+            <a:avLst/>
+          </a:prstGeom>
+        </p:spPr>
+        <p:style>
+          <a:lnRef idx="1">
+            <a:schemeClr val="accent1"/>
+          </a:lnRef>
+          <a:fillRef idx="0">
+            <a:schemeClr val="accent1"/>
+          </a:fillRef>
+          <a:effectRef idx="0">
+            <a:schemeClr val="accent1"/>
+          </a:effectRef>
+          <a:fontRef idx="minor">
+            <a:schemeClr val="tx1"/>
+          </a:fontRef>
+        </p:style>
+      </p:cxnSp>
+      <p:cxnSp>
+        <p:nvCxnSpPr>
+          <p:cNvPr id="89" name="Straight Connector 88"/>
+          <p:cNvCxnSpPr/>
+          <p:nvPr/>
+        </p:nvCxnSpPr>
+        <p:spPr>
+          <a:xfrm>
+            <a:off x="3216000" y="3276000"/>
+            <a:ext cx="842400" cy="0"/>
+          </a:xfrm>
+          <a:prstGeom prst="line">
+            <a:avLst/>
+          </a:prstGeom>
+        </p:spPr>
+        <p:style>
+          <a:lnRef idx="1">
+            <a:schemeClr val="accent1"/>
+          </a:lnRef>
+          <a:fillRef idx="0">
+            <a:schemeClr val="accent1"/>
+          </a:fillRef>
+          <a:effectRef idx="0">
+            <a:schemeClr val="accent1"/>
+          </a:effectRef>
+          <a:fontRef idx="minor">
+            <a:schemeClr val="tx1"/>
+          </a:fontRef>
+        </p:style>
+      </p:cxnSp>
+      <p:cxnSp>
+        <p:nvCxnSpPr>
+          <p:cNvPr id="90" name="Straight Connector 89"/>
+          <p:cNvCxnSpPr/>
+          <p:nvPr/>
+        </p:nvCxnSpPr>
+        <p:spPr>
+          <a:xfrm>
+            <a:off x="4058400" y="3276000"/>
+            <a:ext cx="0" cy="360000"/>
+          </a:xfrm>
+          <a:prstGeom prst="line">
+            <a:avLst/>
+          </a:prstGeom>
+        </p:spPr>
+        <p:style>
+          <a:lnRef idx="1">
+            <a:schemeClr val="accent1"/>
+          </a:lnRef>
+          <a:fillRef idx="0">
+            <a:schemeClr val="accent1"/>
+          </a:fillRef>
+          <a:effectRef idx="0">
+            <a:schemeClr val="accent1"/>
+          </a:effectRef>
+          <a:fontRef idx="minor">
+            <a:schemeClr val="tx1"/>
+          </a:fontRef>
+        </p:style>
+      </p:cxnSp>
+      <p:sp>
+        <p:nvSpPr>
+          <p:cNvPr id="107" name="TextBox 106"/>
+          <p:cNvSpPr txBox="1"/>
+          <p:nvPr/>
+        </p:nvSpPr>
+        <p:spPr>
+          <a:xfrm>
+            <a:off x="2370390" y="3261360"/>
+            <a:ext cx="897810" cy="338554"/>
+          </a:xfrm>
+          <a:prstGeom prst="rect">
+            <a:avLst/>
+          </a:prstGeom>
+          <a:noFill/>
+        </p:spPr>
+        <p:txBody>
+          <a:bodyPr wrap="none" rtlCol="0">
+            <a:spAutoFit/>
+          </a:bodyPr>
+          <a:lstStyle/>
+          <a:p>
+            <a:r>
+              <a:rPr lang="en-GB" sz="1600" dirty="0" smtClean="0"/>
+              <a:t>OPCODE</a:t>
+            </a:r>
+            <a:endParaRPr lang="en-GB" sz="1600" dirty="0" smtClean="0"/>
+          </a:p>
+        </p:txBody>
+      </p:sp>
+      <p:sp>
+        <p:nvSpPr>
+          <p:cNvPr id="108" name="TextBox 107"/>
+          <p:cNvSpPr txBox="1"/>
+          <p:nvPr/>
+        </p:nvSpPr>
+        <p:spPr>
+          <a:xfrm>
+            <a:off x="3584244" y="3312000"/>
+            <a:ext cx="445956" cy="276999"/>
+          </a:xfrm>
+          <a:prstGeom prst="rect">
+            <a:avLst/>
+          </a:prstGeom>
+          <a:noFill/>
+        </p:spPr>
+        <p:txBody>
+          <a:bodyPr wrap="none" rtlCol="0">
+            <a:spAutoFit/>
+          </a:bodyPr>
+          <a:lstStyle/>
+          <a:p>
+            <a:r>
+              <a:rPr lang="en-GB" sz="1200" dirty="0" smtClean="0"/>
+              <a:t>OLD</a:t>
+            </a:r>
+            <a:endParaRPr lang="en-GB" sz="1200" dirty="0"/>
+          </a:p>
+        </p:txBody>
+      </p:sp>
+      <p:cxnSp>
+        <p:nvCxnSpPr>
+          <p:cNvPr id="109" name="Straight Connector 108"/>
+          <p:cNvCxnSpPr/>
+          <p:nvPr/>
+        </p:nvCxnSpPr>
+        <p:spPr>
+          <a:xfrm>
+            <a:off x="4058400" y="3276000"/>
+            <a:ext cx="2037600" cy="0"/>
+          </a:xfrm>
+          <a:prstGeom prst="line">
+            <a:avLst/>
+          </a:prstGeom>
+        </p:spPr>
+        <p:style>
+          <a:lnRef idx="1">
+            <a:schemeClr val="accent1"/>
+          </a:lnRef>
+          <a:fillRef idx="0">
+            <a:schemeClr val="accent1"/>
+          </a:fillRef>
+          <a:effectRef idx="0">
+            <a:schemeClr val="accent1"/>
+          </a:effectRef>
+          <a:fontRef idx="minor">
+            <a:schemeClr val="tx1"/>
+          </a:fontRef>
+        </p:style>
+      </p:cxnSp>
+      <p:cxnSp>
+        <p:nvCxnSpPr>
+          <p:cNvPr id="110" name="Straight Connector 109"/>
+          <p:cNvCxnSpPr/>
+          <p:nvPr/>
+        </p:nvCxnSpPr>
+        <p:spPr>
+          <a:xfrm>
+            <a:off x="4058400" y="3636000"/>
+            <a:ext cx="2037600" cy="0"/>
+          </a:xfrm>
+          <a:prstGeom prst="line">
+            <a:avLst/>
+          </a:prstGeom>
+        </p:spPr>
+        <p:style>
+          <a:lnRef idx="1">
+            <a:schemeClr val="accent1"/>
+          </a:lnRef>
+          <a:fillRef idx="0">
+            <a:schemeClr val="accent1"/>
+          </a:fillRef>
+          <a:effectRef idx="0">
+            <a:schemeClr val="accent1"/>
+          </a:effectRef>
+          <a:fontRef idx="minor">
+            <a:schemeClr val="tx1"/>
+          </a:fontRef>
+        </p:style>
+      </p:cxnSp>
+      <p:sp>
+        <p:nvSpPr>
+          <p:cNvPr id="111" name="TextBox 110"/>
+          <p:cNvSpPr txBox="1"/>
+          <p:nvPr/>
+        </p:nvSpPr>
+        <p:spPr>
+          <a:xfrm>
+            <a:off x="4106400" y="3312000"/>
+            <a:ext cx="495649" cy="276999"/>
+          </a:xfrm>
+          <a:prstGeom prst="rect">
+            <a:avLst/>
+          </a:prstGeom>
+          <a:noFill/>
+        </p:spPr>
+        <p:txBody>
+          <a:bodyPr wrap="none" rtlCol="0">
+            <a:spAutoFit/>
+          </a:bodyPr>
+          <a:lstStyle/>
+          <a:p>
+            <a:r>
+              <a:rPr lang="en-GB" sz="1200" dirty="0" smtClean="0"/>
+              <a:t>NEW</a:t>
+            </a:r>
+            <a:endParaRPr lang="en-GB" sz="1200" dirty="0"/>
+          </a:p>
+        </p:txBody>
+      </p:sp>
+      <p:sp>
+        <p:nvSpPr>
+          <p:cNvPr id="112" name="TextBox 111"/>
+          <p:cNvSpPr txBox="1"/>
+          <p:nvPr/>
+        </p:nvSpPr>
+        <p:spPr>
+          <a:xfrm>
+            <a:off x="2766139" y="3810000"/>
+            <a:ext cx="502061" cy="338554"/>
+          </a:xfrm>
+          <a:prstGeom prst="rect">
+            <a:avLst/>
+          </a:prstGeom>
+          <a:noFill/>
+        </p:spPr>
+        <p:txBody>
+          <a:bodyPr wrap="none" rtlCol="0">
+            <a:spAutoFit/>
+          </a:bodyPr>
+          <a:lstStyle/>
+          <a:p>
+            <a:r>
+              <a:rPr lang="en-GB" sz="1600" dirty="0" smtClean="0"/>
+              <a:t>OLS</a:t>
+            </a:r>
+            <a:endParaRPr lang="en-GB" sz="1600" dirty="0"/>
+          </a:p>
+        </p:txBody>
+      </p:sp>
+      <p:cxnSp>
+        <p:nvCxnSpPr>
+          <p:cNvPr id="113" name="Straight Connector 112"/>
+          <p:cNvCxnSpPr/>
+          <p:nvPr/>
+        </p:nvCxnSpPr>
+        <p:spPr>
+          <a:xfrm>
+            <a:off x="3216000" y="4194000"/>
+            <a:ext cx="1141200" cy="0"/>
+          </a:xfrm>
+          <a:prstGeom prst="line">
+            <a:avLst/>
+          </a:prstGeom>
+        </p:spPr>
+        <p:style>
+          <a:lnRef idx="1">
+            <a:schemeClr val="accent1"/>
+          </a:lnRef>
+          <a:fillRef idx="0">
+            <a:schemeClr val="accent1"/>
+          </a:fillRef>
+          <a:effectRef idx="0">
+            <a:schemeClr val="accent1"/>
+          </a:effectRef>
+          <a:fontRef idx="minor">
+            <a:schemeClr val="tx1"/>
+          </a:fontRef>
+        </p:style>
+      </p:cxnSp>
+      <p:cxnSp>
+        <p:nvCxnSpPr>
+          <p:cNvPr id="118" name="Straight Connector 117"/>
+          <p:cNvCxnSpPr/>
+          <p:nvPr/>
+        </p:nvCxnSpPr>
+        <p:spPr>
+          <a:xfrm>
+            <a:off x="4357200" y="3834000"/>
+            <a:ext cx="0" cy="360000"/>
+          </a:xfrm>
+          <a:prstGeom prst="line">
+            <a:avLst/>
+          </a:prstGeom>
+        </p:spPr>
+        <p:style>
+          <a:lnRef idx="1">
+            <a:schemeClr val="accent1"/>
+          </a:lnRef>
+          <a:fillRef idx="0">
+            <a:schemeClr val="accent1"/>
+          </a:fillRef>
+          <a:effectRef idx="0">
+            <a:schemeClr val="accent1"/>
+          </a:effectRef>
+          <a:fontRef idx="minor">
+            <a:schemeClr val="tx1"/>
+          </a:fontRef>
+        </p:style>
+      </p:cxnSp>
+      <p:cxnSp>
+        <p:nvCxnSpPr>
+          <p:cNvPr id="119" name="Straight Connector 118"/>
+          <p:cNvCxnSpPr/>
+          <p:nvPr/>
+        </p:nvCxnSpPr>
+        <p:spPr>
+          <a:xfrm>
+            <a:off x="4357200" y="3834000"/>
+            <a:ext cx="360000" cy="0"/>
+          </a:xfrm>
+          <a:prstGeom prst="line">
+            <a:avLst/>
+          </a:prstGeom>
+        </p:spPr>
+        <p:style>
+          <a:lnRef idx="1">
+            <a:schemeClr val="accent1"/>
+          </a:lnRef>
+          <a:fillRef idx="0">
+            <a:schemeClr val="accent1"/>
+          </a:fillRef>
+          <a:effectRef idx="0">
+            <a:schemeClr val="accent1"/>
+          </a:effectRef>
+          <a:fontRef idx="minor">
+            <a:schemeClr val="tx1"/>
+          </a:fontRef>
+        </p:style>
+      </p:cxnSp>
+      <p:cxnSp>
+        <p:nvCxnSpPr>
+          <p:cNvPr id="120" name="Straight Connector 119"/>
+          <p:cNvCxnSpPr/>
+          <p:nvPr/>
+        </p:nvCxnSpPr>
+        <p:spPr>
+          <a:xfrm>
+            <a:off x="4717200" y="3834000"/>
+            <a:ext cx="0" cy="360000"/>
+          </a:xfrm>
+          <a:prstGeom prst="line">
+            <a:avLst/>
+          </a:prstGeom>
+        </p:spPr>
+        <p:style>
+          <a:lnRef idx="1">
+            <a:schemeClr val="accent1"/>
+          </a:lnRef>
+          <a:fillRef idx="0">
+            <a:schemeClr val="accent1"/>
+          </a:fillRef>
+          <a:effectRef idx="0">
+            <a:schemeClr val="accent1"/>
+          </a:effectRef>
+          <a:fontRef idx="minor">
+            <a:schemeClr val="tx1"/>
+          </a:fontRef>
+        </p:style>
+      </p:cxnSp>
+      <p:cxnSp>
+        <p:nvCxnSpPr>
+          <p:cNvPr id="121" name="Straight Connector 120"/>
+          <p:cNvCxnSpPr/>
+          <p:nvPr/>
+        </p:nvCxnSpPr>
+        <p:spPr>
+          <a:xfrm>
+            <a:off x="4717200" y="4194000"/>
+            <a:ext cx="1378800" cy="0"/>
+          </a:xfrm>
+          <a:prstGeom prst="line">
+            <a:avLst/>
+          </a:prstGeom>
+        </p:spPr>
+        <p:style>
+          <a:lnRef idx="1">
+            <a:schemeClr val="accent1"/>
+          </a:lnRef>
+          <a:fillRef idx="0">
+            <a:schemeClr val="accent1"/>
+          </a:fillRef>
+          <a:effectRef idx="0">
+            <a:schemeClr val="accent1"/>
+          </a:effectRef>
+          <a:fontRef idx="minor">
+            <a:schemeClr val="tx1"/>
+          </a:fontRef>
+        </p:style>
+      </p:cxnSp>
+      <p:sp>
+        <p:nvSpPr>
+          <p:cNvPr id="122" name="TextBox 121"/>
+          <p:cNvSpPr txBox="1"/>
+          <p:nvPr/>
+        </p:nvSpPr>
+        <p:spPr>
+          <a:xfrm>
+            <a:off x="3155779" y="381000"/>
+            <a:ext cx="2832442" cy="369332"/>
+          </a:xfrm>
+          <a:prstGeom prst="rect">
+            <a:avLst/>
+          </a:prstGeom>
+          <a:noFill/>
+        </p:spPr>
+        <p:txBody>
+          <a:bodyPr wrap="none" rtlCol="0">
+            <a:spAutoFit/>
+          </a:bodyPr>
+          <a:lstStyle/>
+          <a:p>
+            <a:r>
+              <a:rPr lang="en-GB" dirty="0" smtClean="0"/>
+              <a:t>SEQUENCE CHANGE TIMING</a:t>
+            </a:r>
+            <a:endParaRPr lang="en-GB" dirty="0"/>
+          </a:p>
+        </p:txBody>
+      </p:sp>
+    </p:spTree>
+  </p:cSld>
+  <p:clrMapOvr>
+    <a:masterClrMapping/>
+  </p:clrMapOvr>
+</p:sld>
+</file>
+
+<file path=ppt/slides/slide5.xml><?xml version="1.0" encoding="utf-8"?>
+<p:sld xmlns:a="http://schemas.openxmlformats.org/drawingml/2006/main" xmlns:r="http://schemas.openxmlformats.org/officeDocument/2006/relationships" xmlns:p="http://schemas.openxmlformats.org/presentationml/2006/main">
+  <p:cSld>
+    <p:spTree>
+      <p:nvGrpSpPr>
+        <p:cNvPr id="1" name=""/>
+        <p:cNvGrpSpPr/>
+        <p:nvPr/>
+      </p:nvGrpSpPr>
+      <p:grpSpPr>
+        <a:xfrm>
+          <a:off x="0" y="0"/>
+          <a:ext cx="0" cy="0"/>
+          <a:chOff x="0" y="0"/>
+          <a:chExt cx="0" cy="0"/>
+        </a:xfrm>
+      </p:grpSpPr>
+      <p:cxnSp>
+        <p:nvCxnSpPr>
+          <p:cNvPr id="41" name="Straight Connector 40"/>
+          <p:cNvCxnSpPr/>
+          <p:nvPr/>
+        </p:nvCxnSpPr>
+        <p:spPr>
+          <a:xfrm>
+            <a:off x="2724600" y="1295400"/>
+            <a:ext cx="0" cy="3132000"/>
+          </a:xfrm>
+          <a:prstGeom prst="line">
+            <a:avLst/>
+          </a:prstGeom>
+          <a:ln>
+            <a:solidFill>
+              <a:schemeClr val="bg1">
+                <a:lumMod val="75000"/>
+              </a:schemeClr>
+            </a:solidFill>
+            <a:prstDash val="sysDot"/>
+          </a:ln>
+        </p:spPr>
+        <p:style>
+          <a:lnRef idx="1">
+            <a:schemeClr val="accent1"/>
+          </a:lnRef>
+          <a:fillRef idx="0">
+            <a:schemeClr val="accent1"/>
+          </a:fillRef>
+          <a:effectRef idx="0">
+            <a:schemeClr val="accent1"/>
+          </a:effectRef>
+          <a:fontRef idx="minor">
+            <a:schemeClr val="tx1"/>
+          </a:fontRef>
+        </p:style>
+      </p:cxnSp>
+      <p:cxnSp>
+        <p:nvCxnSpPr>
+          <p:cNvPr id="42" name="Straight Connector 41"/>
+          <p:cNvCxnSpPr/>
+          <p:nvPr/>
+        </p:nvCxnSpPr>
+        <p:spPr>
+          <a:xfrm>
+            <a:off x="3444600" y="1295400"/>
+            <a:ext cx="0" cy="3132000"/>
+          </a:xfrm>
+          <a:prstGeom prst="line">
+            <a:avLst/>
+          </a:prstGeom>
+          <a:ln>
+            <a:solidFill>
+              <a:schemeClr val="bg1">
+                <a:lumMod val="75000"/>
+              </a:schemeClr>
+            </a:solidFill>
+            <a:prstDash val="sysDot"/>
+          </a:ln>
+        </p:spPr>
+        <p:style>
+          <a:lnRef idx="1">
+            <a:schemeClr val="accent1"/>
+          </a:lnRef>
+          <a:fillRef idx="0">
+            <a:schemeClr val="accent1"/>
+          </a:fillRef>
+          <a:effectRef idx="0">
+            <a:schemeClr val="accent1"/>
+          </a:effectRef>
+          <a:fontRef idx="minor">
+            <a:schemeClr val="tx1"/>
+          </a:fontRef>
+        </p:style>
+      </p:cxnSp>
+      <p:cxnSp>
+        <p:nvCxnSpPr>
+          <p:cNvPr id="43" name="Straight Connector 42"/>
+          <p:cNvCxnSpPr/>
+          <p:nvPr/>
+        </p:nvCxnSpPr>
+        <p:spPr>
+          <a:xfrm>
+            <a:off x="4164600" y="1295400"/>
+            <a:ext cx="0" cy="3132000"/>
+          </a:xfrm>
+          <a:prstGeom prst="line">
+            <a:avLst/>
+          </a:prstGeom>
+          <a:ln>
+            <a:solidFill>
+              <a:schemeClr val="bg1">
+                <a:lumMod val="75000"/>
+              </a:schemeClr>
+            </a:solidFill>
+            <a:prstDash val="sysDot"/>
+          </a:ln>
+        </p:spPr>
+        <p:style>
+          <a:lnRef idx="1">
+            <a:schemeClr val="accent1"/>
+          </a:lnRef>
+          <a:fillRef idx="0">
+            <a:schemeClr val="accent1"/>
+          </a:fillRef>
+          <a:effectRef idx="0">
+            <a:schemeClr val="accent1"/>
+          </a:effectRef>
+          <a:fontRef idx="minor">
+            <a:schemeClr val="tx1"/>
+          </a:fontRef>
+        </p:style>
+      </p:cxnSp>
+      <p:cxnSp>
+        <p:nvCxnSpPr>
+          <p:cNvPr id="44" name="Straight Connector 43"/>
+          <p:cNvCxnSpPr/>
+          <p:nvPr/>
+        </p:nvCxnSpPr>
+        <p:spPr>
+          <a:xfrm>
+            <a:off x="4884600" y="1295400"/>
+            <a:ext cx="0" cy="3132000"/>
+          </a:xfrm>
+          <a:prstGeom prst="line">
+            <a:avLst/>
+          </a:prstGeom>
+          <a:ln>
+            <a:solidFill>
+              <a:schemeClr val="bg1">
+                <a:lumMod val="75000"/>
+              </a:schemeClr>
+            </a:solidFill>
+            <a:prstDash val="sysDot"/>
+          </a:ln>
+        </p:spPr>
+        <p:style>
+          <a:lnRef idx="1">
+            <a:schemeClr val="accent1"/>
+          </a:lnRef>
+          <a:fillRef idx="0">
+            <a:schemeClr val="accent1"/>
+          </a:fillRef>
+          <a:effectRef idx="0">
+            <a:schemeClr val="accent1"/>
+          </a:effectRef>
+          <a:fontRef idx="minor">
+            <a:schemeClr val="tx1"/>
+          </a:fontRef>
+        </p:style>
+      </p:cxnSp>
+      <p:cxnSp>
+        <p:nvCxnSpPr>
+          <p:cNvPr id="18" name="Straight Connector 17"/>
+          <p:cNvCxnSpPr/>
+          <p:nvPr/>
+        </p:nvCxnSpPr>
+        <p:spPr>
+          <a:xfrm>
+            <a:off x="2724600" y="1600200"/>
+            <a:ext cx="360000" cy="0"/>
+          </a:xfrm>
+          <a:prstGeom prst="line">
+            <a:avLst/>
+          </a:prstGeom>
+        </p:spPr>
+        <p:style>
+          <a:lnRef idx="1">
+            <a:schemeClr val="accent1"/>
+          </a:lnRef>
+          <a:fillRef idx="0">
+            <a:schemeClr val="accent1"/>
+          </a:fillRef>
+          <a:effectRef idx="0">
+            <a:schemeClr val="accent1"/>
+          </a:effectRef>
+          <a:fontRef idx="minor">
+            <a:schemeClr val="tx1"/>
+          </a:fontRef>
+        </p:style>
+      </p:cxnSp>
+      <p:cxnSp>
+        <p:nvCxnSpPr>
+          <p:cNvPr id="21" name="Straight Connector 20"/>
+          <p:cNvCxnSpPr/>
+          <p:nvPr/>
+        </p:nvCxnSpPr>
+        <p:spPr>
+          <a:xfrm>
+            <a:off x="2724600" y="1600200"/>
+            <a:ext cx="0" cy="360000"/>
+          </a:xfrm>
+          <a:prstGeom prst="line">
+            <a:avLst/>
+          </a:prstGeom>
+        </p:spPr>
+        <p:style>
+          <a:lnRef idx="1">
+            <a:schemeClr val="accent1"/>
+          </a:lnRef>
+          <a:fillRef idx="0">
+            <a:schemeClr val="accent1"/>
+          </a:fillRef>
+          <a:effectRef idx="0">
+            <a:schemeClr val="accent1"/>
+          </a:effectRef>
+          <a:fontRef idx="minor">
+            <a:schemeClr val="tx1"/>
+          </a:fontRef>
+        </p:style>
+      </p:cxnSp>
+      <p:cxnSp>
+        <p:nvCxnSpPr>
+          <p:cNvPr id="22" name="Straight Connector 21"/>
+          <p:cNvCxnSpPr/>
+          <p:nvPr/>
+        </p:nvCxnSpPr>
+        <p:spPr>
+          <a:xfrm>
+            <a:off x="3084600" y="1600200"/>
+            <a:ext cx="0" cy="360000"/>
+          </a:xfrm>
+          <a:prstGeom prst="line">
+            <a:avLst/>
+          </a:prstGeom>
+        </p:spPr>
+        <p:style>
+          <a:lnRef idx="1">
+            <a:schemeClr val="accent1"/>
+          </a:lnRef>
+          <a:fillRef idx="0">
+            <a:schemeClr val="accent1"/>
+          </a:fillRef>
+          <a:effectRef idx="0">
+            <a:schemeClr val="accent1"/>
+          </a:effectRef>
+          <a:fontRef idx="minor">
+            <a:schemeClr val="tx1"/>
+          </a:fontRef>
+        </p:style>
+      </p:cxnSp>
+      <p:cxnSp>
+        <p:nvCxnSpPr>
+          <p:cNvPr id="23" name="Straight Connector 22"/>
+          <p:cNvCxnSpPr/>
+          <p:nvPr/>
+        </p:nvCxnSpPr>
+        <p:spPr>
+          <a:xfrm>
+            <a:off x="3084600" y="1960200"/>
+            <a:ext cx="360000" cy="0"/>
+          </a:xfrm>
+          <a:prstGeom prst="line">
+            <a:avLst/>
+          </a:prstGeom>
+        </p:spPr>
+        <p:style>
+          <a:lnRef idx="1">
+            <a:schemeClr val="accent1"/>
+          </a:lnRef>
+          <a:fillRef idx="0">
+            <a:schemeClr val="accent1"/>
+          </a:fillRef>
+          <a:effectRef idx="0">
+            <a:schemeClr val="accent1"/>
+          </a:effectRef>
+          <a:fontRef idx="minor">
+            <a:schemeClr val="tx1"/>
+          </a:fontRef>
+        </p:style>
+      </p:cxnSp>
+      <p:cxnSp>
+        <p:nvCxnSpPr>
+          <p:cNvPr id="24" name="Straight Connector 23"/>
+          <p:cNvCxnSpPr/>
+          <p:nvPr/>
+        </p:nvCxnSpPr>
+        <p:spPr>
+          <a:xfrm>
+            <a:off x="3444600" y="1600200"/>
+            <a:ext cx="360000" cy="0"/>
+          </a:xfrm>
+          <a:prstGeom prst="line">
+            <a:avLst/>
+          </a:prstGeom>
+        </p:spPr>
+        <p:style>
+          <a:lnRef idx="1">
+            <a:schemeClr val="accent1"/>
+          </a:lnRef>
+          <a:fillRef idx="0">
+            <a:schemeClr val="accent1"/>
+          </a:fillRef>
+          <a:effectRef idx="0">
+            <a:schemeClr val="accent1"/>
+          </a:effectRef>
+          <a:fontRef idx="minor">
+            <a:schemeClr val="tx1"/>
+          </a:fontRef>
+        </p:style>
+      </p:cxnSp>
+      <p:cxnSp>
+        <p:nvCxnSpPr>
+          <p:cNvPr id="25" name="Straight Connector 24"/>
+          <p:cNvCxnSpPr/>
+          <p:nvPr/>
+        </p:nvCxnSpPr>
+        <p:spPr>
+          <a:xfrm>
+            <a:off x="3444600" y="1600200"/>
+            <a:ext cx="0" cy="360000"/>
+          </a:xfrm>
+          <a:prstGeom prst="line">
+            <a:avLst/>
+          </a:prstGeom>
+        </p:spPr>
+        <p:style>
+          <a:lnRef idx="1">
+            <a:schemeClr val="accent1"/>
+          </a:lnRef>
+          <a:fillRef idx="0">
+            <a:schemeClr val="accent1"/>
+          </a:fillRef>
+          <a:effectRef idx="0">
+            <a:schemeClr val="accent1"/>
+          </a:effectRef>
+          <a:fontRef idx="minor">
+            <a:schemeClr val="tx1"/>
+          </a:fontRef>
+        </p:style>
+      </p:cxnSp>
+      <p:cxnSp>
+        <p:nvCxnSpPr>
+          <p:cNvPr id="26" name="Straight Connector 25"/>
+          <p:cNvCxnSpPr/>
+          <p:nvPr/>
+        </p:nvCxnSpPr>
+        <p:spPr>
+          <a:xfrm>
+            <a:off x="3804600" y="1600200"/>
+            <a:ext cx="0" cy="360000"/>
+          </a:xfrm>
+          <a:prstGeom prst="line">
+            <a:avLst/>
+          </a:prstGeom>
+        </p:spPr>
+        <p:style>
+          <a:lnRef idx="1">
+            <a:schemeClr val="accent1"/>
+          </a:lnRef>
+          <a:fillRef idx="0">
+            <a:schemeClr val="accent1"/>
+          </a:fillRef>
+          <a:effectRef idx="0">
+            <a:schemeClr val="accent1"/>
+          </a:effectRef>
+          <a:fontRef idx="minor">
+            <a:schemeClr val="tx1"/>
+          </a:fontRef>
+        </p:style>
+      </p:cxnSp>
+      <p:cxnSp>
+        <p:nvCxnSpPr>
+          <p:cNvPr id="27" name="Straight Connector 26"/>
+          <p:cNvCxnSpPr/>
+          <p:nvPr/>
+        </p:nvCxnSpPr>
+        <p:spPr>
+          <a:xfrm>
+            <a:off x="3804600" y="1960200"/>
+            <a:ext cx="360000" cy="0"/>
+          </a:xfrm>
+          <a:prstGeom prst="line">
+            <a:avLst/>
+          </a:prstGeom>
+        </p:spPr>
+        <p:style>
+          <a:lnRef idx="1">
+            <a:schemeClr val="accent1"/>
+          </a:lnRef>
+          <a:fillRef idx="0">
+            <a:schemeClr val="accent1"/>
+          </a:fillRef>
+          <a:effectRef idx="0">
+            <a:schemeClr val="accent1"/>
+          </a:effectRef>
+          <a:fontRef idx="minor">
+            <a:schemeClr val="tx1"/>
+          </a:fontRef>
+        </p:style>
+      </p:cxnSp>
+      <p:cxnSp>
+        <p:nvCxnSpPr>
+          <p:cNvPr id="28" name="Straight Connector 27"/>
+          <p:cNvCxnSpPr/>
+          <p:nvPr/>
+        </p:nvCxnSpPr>
+        <p:spPr>
+          <a:xfrm>
+            <a:off x="4164600" y="1600200"/>
+            <a:ext cx="360000" cy="0"/>
+          </a:xfrm>
+          <a:prstGeom prst="line">
+            <a:avLst/>
+          </a:prstGeom>
+        </p:spPr>
+        <p:style>
+          <a:lnRef idx="1">
+            <a:schemeClr val="accent1"/>
+          </a:lnRef>
+          <a:fillRef idx="0">
+            <a:schemeClr val="accent1"/>
+          </a:fillRef>
+          <a:effectRef idx="0">
+            <a:schemeClr val="accent1"/>
+          </a:effectRef>
+          <a:fontRef idx="minor">
+            <a:schemeClr val="tx1"/>
+          </a:fontRef>
+        </p:style>
+      </p:cxnSp>
+      <p:cxnSp>
+        <p:nvCxnSpPr>
+          <p:cNvPr id="29" name="Straight Connector 28"/>
+          <p:cNvCxnSpPr/>
+          <p:nvPr/>
+        </p:nvCxnSpPr>
+        <p:spPr>
+          <a:xfrm>
+            <a:off x="4164600" y="1600200"/>
+            <a:ext cx="0" cy="360000"/>
+          </a:xfrm>
+          <a:prstGeom prst="line">
+            <a:avLst/>
+          </a:prstGeom>
+        </p:spPr>
+        <p:style>
+          <a:lnRef idx="1">
+            <a:schemeClr val="accent1"/>
+          </a:lnRef>
+          <a:fillRef idx="0">
+            <a:schemeClr val="accent1"/>
+          </a:fillRef>
+          <a:effectRef idx="0">
+            <a:schemeClr val="accent1"/>
+          </a:effectRef>
+          <a:fontRef idx="minor">
+            <a:schemeClr val="tx1"/>
+          </a:fontRef>
+        </p:style>
+      </p:cxnSp>
+      <p:cxnSp>
+        <p:nvCxnSpPr>
+          <p:cNvPr id="30" name="Straight Connector 29"/>
+          <p:cNvCxnSpPr/>
+          <p:nvPr/>
+        </p:nvCxnSpPr>
+        <p:spPr>
+          <a:xfrm>
+            <a:off x="4524600" y="1600200"/>
+            <a:ext cx="0" cy="360000"/>
+          </a:xfrm>
+          <a:prstGeom prst="line">
+            <a:avLst/>
+          </a:prstGeom>
+        </p:spPr>
+        <p:style>
+          <a:lnRef idx="1">
+            <a:schemeClr val="accent1"/>
+          </a:lnRef>
+          <a:fillRef idx="0">
+            <a:schemeClr val="accent1"/>
+          </a:fillRef>
+          <a:effectRef idx="0">
+            <a:schemeClr val="accent1"/>
+          </a:effectRef>
+          <a:fontRef idx="minor">
+            <a:schemeClr val="tx1"/>
+          </a:fontRef>
+        </p:style>
+      </p:cxnSp>
+      <p:cxnSp>
+        <p:nvCxnSpPr>
+          <p:cNvPr id="31" name="Straight Connector 30"/>
+          <p:cNvCxnSpPr/>
+          <p:nvPr/>
+        </p:nvCxnSpPr>
+        <p:spPr>
+          <a:xfrm>
+            <a:off x="4524600" y="1960200"/>
+            <a:ext cx="360000" cy="0"/>
+          </a:xfrm>
+          <a:prstGeom prst="line">
+            <a:avLst/>
+          </a:prstGeom>
+        </p:spPr>
+        <p:style>
+          <a:lnRef idx="1">
+            <a:schemeClr val="accent1"/>
+          </a:lnRef>
+          <a:fillRef idx="0">
+            <a:schemeClr val="accent1"/>
+          </a:fillRef>
+          <a:effectRef idx="0">
+            <a:schemeClr val="accent1"/>
+          </a:effectRef>
+          <a:fontRef idx="minor">
+            <a:schemeClr val="tx1"/>
+          </a:fontRef>
+        </p:style>
+      </p:cxnSp>
+      <p:cxnSp>
+        <p:nvCxnSpPr>
+          <p:cNvPr id="33" name="Straight Connector 32"/>
+          <p:cNvCxnSpPr/>
+          <p:nvPr/>
+        </p:nvCxnSpPr>
+        <p:spPr>
+          <a:xfrm>
+            <a:off x="4884600" y="1600200"/>
+            <a:ext cx="0" cy="360000"/>
+          </a:xfrm>
+          <a:prstGeom prst="line">
+            <a:avLst/>
+          </a:prstGeom>
+        </p:spPr>
+        <p:style>
+          <a:lnRef idx="1">
+            <a:schemeClr val="accent1"/>
+          </a:lnRef>
+          <a:fillRef idx="0">
+            <a:schemeClr val="accent1"/>
+          </a:fillRef>
+          <a:effectRef idx="0">
+            <a:schemeClr val="accent1"/>
+          </a:effectRef>
+          <a:fontRef idx="minor">
+            <a:schemeClr val="tx1"/>
+          </a:fontRef>
+        </p:style>
+      </p:cxnSp>
+      <p:sp>
+        <p:nvSpPr>
+          <p:cNvPr id="46" name="TextBox 45"/>
+          <p:cNvSpPr txBox="1"/>
+          <p:nvPr/>
+        </p:nvSpPr>
+        <p:spPr>
+          <a:xfrm>
+            <a:off x="1328995" y="1619250"/>
+            <a:ext cx="728405" cy="338554"/>
+          </a:xfrm>
+          <a:prstGeom prst="rect">
+            <a:avLst/>
+          </a:prstGeom>
+          <a:noFill/>
+        </p:spPr>
+        <p:txBody>
+          <a:bodyPr wrap="none" rtlCol="0">
+            <a:spAutoFit/>
+          </a:bodyPr>
+          <a:lstStyle/>
+          <a:p>
+            <a:r>
+              <a:rPr lang="en-GB" sz="1600" dirty="0" smtClean="0"/>
+              <a:t>CLOCK</a:t>
+            </a:r>
+            <a:endParaRPr lang="en-GB" sz="1600" dirty="0"/>
+          </a:p>
+        </p:txBody>
+      </p:sp>
+      <p:sp>
+        <p:nvSpPr>
+          <p:cNvPr id="54" name="TextBox 53"/>
+          <p:cNvSpPr txBox="1"/>
+          <p:nvPr/>
+        </p:nvSpPr>
+        <p:spPr>
+          <a:xfrm>
+            <a:off x="1366570" y="2171700"/>
+            <a:ext cx="690830" cy="338554"/>
+          </a:xfrm>
+          <a:prstGeom prst="rect">
+            <a:avLst/>
+          </a:prstGeom>
+          <a:noFill/>
+        </p:spPr>
+        <p:txBody>
+          <a:bodyPr wrap="none" rtlCol="0">
+            <a:spAutoFit/>
+          </a:bodyPr>
+          <a:lstStyle/>
+          <a:p>
+            <a:r>
+              <a:rPr lang="en-GB" sz="1600" dirty="0" smtClean="0"/>
+              <a:t>RESET</a:t>
+            </a:r>
+            <a:endParaRPr lang="en-GB" sz="1600" dirty="0"/>
+          </a:p>
+        </p:txBody>
+      </p:sp>
+      <p:cxnSp>
+        <p:nvCxnSpPr>
+          <p:cNvPr id="65" name="Straight Connector 64"/>
+          <p:cNvCxnSpPr/>
+          <p:nvPr/>
+        </p:nvCxnSpPr>
+        <p:spPr>
+          <a:xfrm>
+            <a:off x="3505800" y="2154600"/>
+            <a:ext cx="0" cy="360000"/>
+          </a:xfrm>
+          <a:prstGeom prst="line">
+            <a:avLst/>
+          </a:prstGeom>
+        </p:spPr>
+        <p:style>
+          <a:lnRef idx="1">
+            <a:schemeClr val="accent1"/>
+          </a:lnRef>
+          <a:fillRef idx="0">
+            <a:schemeClr val="accent1"/>
+          </a:fillRef>
+          <a:effectRef idx="0">
+            <a:schemeClr val="accent1"/>
+          </a:effectRef>
+          <a:fontRef idx="minor">
+            <a:schemeClr val="tx1"/>
+          </a:fontRef>
+        </p:style>
+      </p:cxnSp>
+      <p:cxnSp>
+        <p:nvCxnSpPr>
+          <p:cNvPr id="66" name="Straight Connector 65"/>
+          <p:cNvCxnSpPr/>
+          <p:nvPr/>
+        </p:nvCxnSpPr>
+        <p:spPr>
+          <a:xfrm>
+            <a:off x="2005200" y="2159000"/>
+            <a:ext cx="1501200" cy="0"/>
+          </a:xfrm>
+          <a:prstGeom prst="line">
+            <a:avLst/>
+          </a:prstGeom>
+        </p:spPr>
+        <p:style>
+          <a:lnRef idx="1">
+            <a:schemeClr val="accent1"/>
+          </a:lnRef>
+          <a:fillRef idx="0">
+            <a:schemeClr val="accent1"/>
+          </a:fillRef>
+          <a:effectRef idx="0">
+            <a:schemeClr val="accent1"/>
+          </a:effectRef>
+          <a:fontRef idx="minor">
+            <a:schemeClr val="tx1"/>
+          </a:fontRef>
+        </p:style>
+      </p:cxnSp>
+      <p:cxnSp>
+        <p:nvCxnSpPr>
+          <p:cNvPr id="67" name="Straight Connector 66"/>
+          <p:cNvCxnSpPr/>
+          <p:nvPr/>
+        </p:nvCxnSpPr>
+        <p:spPr>
+          <a:xfrm>
+            <a:off x="3505800" y="2514600"/>
+            <a:ext cx="1378800" cy="0"/>
+          </a:xfrm>
+          <a:prstGeom prst="line">
+            <a:avLst/>
+          </a:prstGeom>
+        </p:spPr>
+        <p:style>
+          <a:lnRef idx="1">
+            <a:schemeClr val="accent1"/>
+          </a:lnRef>
+          <a:fillRef idx="0">
+            <a:schemeClr val="accent1"/>
+          </a:fillRef>
+          <a:effectRef idx="0">
+            <a:schemeClr val="accent1"/>
+          </a:effectRef>
+          <a:fontRef idx="minor">
+            <a:schemeClr val="tx1"/>
+          </a:fontRef>
+        </p:style>
+      </p:cxnSp>
+      <p:cxnSp>
+        <p:nvCxnSpPr>
+          <p:cNvPr id="87" name="Straight Arrow Connector 86"/>
+          <p:cNvCxnSpPr/>
+          <p:nvPr/>
+        </p:nvCxnSpPr>
+        <p:spPr>
+          <a:xfrm>
+            <a:off x="2724600" y="1295400"/>
+            <a:ext cx="720000" cy="0"/>
+          </a:xfrm>
+          <a:prstGeom prst="straightConnector1">
+            <a:avLst/>
+          </a:prstGeom>
+          <a:ln>
+            <a:headEnd type="arrow" w="sm" len="sm"/>
+            <a:tailEnd type="arrow" w="sm" len="sm"/>
+          </a:ln>
+        </p:spPr>
+        <p:style>
+          <a:lnRef idx="1">
+            <a:schemeClr val="accent1"/>
+          </a:lnRef>
+          <a:fillRef idx="0">
+            <a:schemeClr val="accent1"/>
+          </a:fillRef>
+          <a:effectRef idx="0">
+            <a:schemeClr val="accent1"/>
+          </a:effectRef>
+          <a:fontRef idx="minor">
+            <a:schemeClr val="tx1"/>
+          </a:fontRef>
+        </p:style>
+      </p:cxnSp>
+      <p:cxnSp>
+        <p:nvCxnSpPr>
+          <p:cNvPr id="88" name="Straight Arrow Connector 87"/>
+          <p:cNvCxnSpPr/>
+          <p:nvPr/>
+        </p:nvCxnSpPr>
+        <p:spPr>
+          <a:xfrm>
+            <a:off x="3444600" y="1295400"/>
+            <a:ext cx="720000" cy="0"/>
+          </a:xfrm>
+          <a:prstGeom prst="straightConnector1">
+            <a:avLst/>
+          </a:prstGeom>
+          <a:ln>
+            <a:headEnd type="arrow" w="sm" len="sm"/>
+            <a:tailEnd type="arrow" w="sm" len="sm"/>
+          </a:ln>
+        </p:spPr>
+        <p:style>
+          <a:lnRef idx="1">
+            <a:schemeClr val="accent1"/>
+          </a:lnRef>
+          <a:fillRef idx="0">
+            <a:schemeClr val="accent1"/>
+          </a:fillRef>
+          <a:effectRef idx="0">
+            <a:schemeClr val="accent1"/>
+          </a:effectRef>
+          <a:fontRef idx="minor">
+            <a:schemeClr val="tx1"/>
+          </a:fontRef>
+        </p:style>
+      </p:cxnSp>
+      <p:cxnSp>
+        <p:nvCxnSpPr>
+          <p:cNvPr id="91" name="Straight Arrow Connector 90"/>
+          <p:cNvCxnSpPr/>
+          <p:nvPr/>
+        </p:nvCxnSpPr>
+        <p:spPr>
+          <a:xfrm>
+            <a:off x="4164600" y="1295400"/>
+            <a:ext cx="720000" cy="0"/>
+          </a:xfrm>
+          <a:prstGeom prst="straightConnector1">
+            <a:avLst/>
+          </a:prstGeom>
+          <a:ln>
+            <a:headEnd type="arrow" w="sm" len="sm"/>
+            <a:tailEnd type="arrow" w="sm" len="sm"/>
+          </a:ln>
+        </p:spPr>
+        <p:style>
+          <a:lnRef idx="1">
+            <a:schemeClr val="accent1"/>
+          </a:lnRef>
+          <a:fillRef idx="0">
+            <a:schemeClr val="accent1"/>
+          </a:fillRef>
+          <a:effectRef idx="0">
+            <a:schemeClr val="accent1"/>
+          </a:effectRef>
+          <a:fontRef idx="minor">
+            <a:schemeClr val="tx1"/>
+          </a:fontRef>
+        </p:style>
+      </p:cxnSp>
+      <p:sp>
+        <p:nvSpPr>
+          <p:cNvPr id="100" name="TextBox 99"/>
+          <p:cNvSpPr txBox="1"/>
+          <p:nvPr/>
+        </p:nvSpPr>
+        <p:spPr>
+          <a:xfrm>
+            <a:off x="2943246" y="990600"/>
+            <a:ext cx="288862" cy="338554"/>
+          </a:xfrm>
+          <a:prstGeom prst="rect">
+            <a:avLst/>
+          </a:prstGeom>
+          <a:noFill/>
+        </p:spPr>
+        <p:txBody>
+          <a:bodyPr wrap="none" rtlCol="0">
+            <a:spAutoFit/>
+          </a:bodyPr>
+          <a:lstStyle/>
+          <a:p>
+            <a:r>
+              <a:rPr lang="en-GB" sz="1600" dirty="0" smtClean="0"/>
+              <a:t>0</a:t>
+            </a:r>
+            <a:endParaRPr lang="en-GB" sz="1600" dirty="0"/>
+          </a:p>
+        </p:txBody>
+      </p:sp>
+      <p:sp>
+        <p:nvSpPr>
+          <p:cNvPr id="101" name="TextBox 100"/>
+          <p:cNvSpPr txBox="1"/>
+          <p:nvPr/>
+        </p:nvSpPr>
+        <p:spPr>
+          <a:xfrm>
+            <a:off x="3676692" y="990600"/>
+            <a:ext cx="288862" cy="338554"/>
+          </a:xfrm>
+          <a:prstGeom prst="rect">
+            <a:avLst/>
+          </a:prstGeom>
+          <a:noFill/>
+        </p:spPr>
+        <p:txBody>
+          <a:bodyPr wrap="none" rtlCol="0">
+            <a:spAutoFit/>
+          </a:bodyPr>
+          <a:lstStyle/>
+          <a:p>
+            <a:r>
+              <a:rPr lang="en-GB" sz="1600" dirty="0" smtClean="0"/>
+              <a:t>0</a:t>
+            </a:r>
+            <a:endParaRPr lang="en-GB" sz="1600" dirty="0"/>
+          </a:p>
+        </p:txBody>
+      </p:sp>
+      <p:sp>
+        <p:nvSpPr>
+          <p:cNvPr id="102" name="TextBox 101"/>
+          <p:cNvSpPr txBox="1"/>
+          <p:nvPr/>
+        </p:nvSpPr>
+        <p:spPr>
+          <a:xfrm>
+            <a:off x="4410138" y="990600"/>
+            <a:ext cx="288862" cy="338554"/>
+          </a:xfrm>
+          <a:prstGeom prst="rect">
+            <a:avLst/>
+          </a:prstGeom>
+          <a:noFill/>
+        </p:spPr>
+        <p:txBody>
+          <a:bodyPr wrap="none" rtlCol="0">
+            <a:spAutoFit/>
+          </a:bodyPr>
+          <a:lstStyle/>
+          <a:p>
+            <a:r>
+              <a:rPr lang="en-GB" sz="1600" dirty="0" smtClean="0"/>
+              <a:t>1</a:t>
+            </a:r>
+            <a:endParaRPr lang="en-GB" sz="1600" dirty="0"/>
+          </a:p>
+        </p:txBody>
+      </p:sp>
+      <p:sp>
+        <p:nvSpPr>
+          <p:cNvPr id="55" name="TextBox 54"/>
+          <p:cNvSpPr txBox="1"/>
+          <p:nvPr/>
+        </p:nvSpPr>
+        <p:spPr>
+          <a:xfrm>
+            <a:off x="1473394" y="1066800"/>
+            <a:ext cx="584006" cy="338554"/>
+          </a:xfrm>
+          <a:prstGeom prst="rect">
+            <a:avLst/>
+          </a:prstGeom>
+          <a:noFill/>
+        </p:spPr>
+        <p:txBody>
+          <a:bodyPr wrap="none" rtlCol="0">
+            <a:spAutoFit/>
+          </a:bodyPr>
+          <a:lstStyle/>
+          <a:p>
+            <a:r>
+              <a:rPr lang="en-GB" sz="1600" dirty="0" smtClean="0"/>
+              <a:t>STEP</a:t>
+            </a:r>
+            <a:endParaRPr lang="en-GB" sz="1600" dirty="0"/>
+          </a:p>
+        </p:txBody>
+      </p:sp>
+      <p:cxnSp>
+        <p:nvCxnSpPr>
+          <p:cNvPr id="79" name="Straight Connector 78"/>
+          <p:cNvCxnSpPr/>
+          <p:nvPr/>
+        </p:nvCxnSpPr>
+        <p:spPr>
+          <a:xfrm>
+            <a:off x="2005200" y="1295400"/>
+            <a:ext cx="0" cy="3132000"/>
+          </a:xfrm>
+          <a:prstGeom prst="line">
+            <a:avLst/>
+          </a:prstGeom>
+          <a:ln>
+            <a:solidFill>
+              <a:schemeClr val="bg1">
+                <a:lumMod val="75000"/>
+              </a:schemeClr>
+            </a:solidFill>
+            <a:prstDash val="sysDot"/>
+          </a:ln>
+        </p:spPr>
+        <p:style>
+          <a:lnRef idx="1">
+            <a:schemeClr val="accent1"/>
+          </a:lnRef>
+          <a:fillRef idx="0">
+            <a:schemeClr val="accent1"/>
+          </a:fillRef>
+          <a:effectRef idx="0">
+            <a:schemeClr val="accent1"/>
+          </a:effectRef>
+          <a:fontRef idx="minor">
+            <a:schemeClr val="tx1"/>
+          </a:fontRef>
+        </p:style>
+      </p:cxnSp>
+      <p:cxnSp>
+        <p:nvCxnSpPr>
+          <p:cNvPr id="80" name="Straight Arrow Connector 79"/>
+          <p:cNvCxnSpPr/>
+          <p:nvPr/>
+        </p:nvCxnSpPr>
+        <p:spPr>
+          <a:xfrm>
+            <a:off x="2005200" y="1295400"/>
+            <a:ext cx="720000" cy="0"/>
+          </a:xfrm>
+          <a:prstGeom prst="straightConnector1">
+            <a:avLst/>
+          </a:prstGeom>
+          <a:ln>
+            <a:headEnd type="arrow" w="sm" len="sm"/>
+            <a:tailEnd type="arrow" w="sm" len="sm"/>
+          </a:ln>
+        </p:spPr>
+        <p:style>
+          <a:lnRef idx="1">
+            <a:schemeClr val="accent1"/>
+          </a:lnRef>
+          <a:fillRef idx="0">
+            <a:schemeClr val="accent1"/>
+          </a:fillRef>
+          <a:effectRef idx="0">
+            <a:schemeClr val="accent1"/>
+          </a:effectRef>
+          <a:fontRef idx="minor">
+            <a:schemeClr val="tx1"/>
+          </a:fontRef>
+        </p:style>
+      </p:cxnSp>
+      <p:sp>
+        <p:nvSpPr>
+          <p:cNvPr id="81" name="TextBox 80"/>
+          <p:cNvSpPr txBox="1"/>
+          <p:nvPr/>
+        </p:nvSpPr>
+        <p:spPr>
+          <a:xfrm>
+            <a:off x="2209800" y="990600"/>
+            <a:ext cx="288862" cy="338554"/>
+          </a:xfrm>
+          <a:prstGeom prst="rect">
+            <a:avLst/>
+          </a:prstGeom>
+          <a:noFill/>
+        </p:spPr>
+        <p:txBody>
+          <a:bodyPr wrap="none" rtlCol="0">
+            <a:spAutoFit/>
+          </a:bodyPr>
+          <a:lstStyle/>
+          <a:p>
+            <a:r>
+              <a:rPr lang="en-GB" sz="1600" dirty="0" smtClean="0"/>
+              <a:t>0</a:t>
+            </a:r>
+            <a:endParaRPr lang="en-GB" sz="1600" dirty="0"/>
+          </a:p>
+        </p:txBody>
+      </p:sp>
+      <p:cxnSp>
+        <p:nvCxnSpPr>
+          <p:cNvPr id="82" name="Straight Connector 81"/>
+          <p:cNvCxnSpPr/>
+          <p:nvPr/>
+        </p:nvCxnSpPr>
+        <p:spPr>
+          <a:xfrm>
+            <a:off x="2005200" y="1600200"/>
+            <a:ext cx="360000" cy="0"/>
+          </a:xfrm>
+          <a:prstGeom prst="line">
+            <a:avLst/>
+          </a:prstGeom>
+        </p:spPr>
+        <p:style>
+          <a:lnRef idx="1">
+            <a:schemeClr val="accent1"/>
+          </a:lnRef>
+          <a:fillRef idx="0">
+            <a:schemeClr val="accent1"/>
+          </a:fillRef>
+          <a:effectRef idx="0">
+            <a:schemeClr val="accent1"/>
+          </a:effectRef>
+          <a:fontRef idx="minor">
+            <a:schemeClr val="tx1"/>
+          </a:fontRef>
+        </p:style>
+      </p:cxnSp>
+      <p:cxnSp>
+        <p:nvCxnSpPr>
+          <p:cNvPr id="83" name="Straight Connector 82"/>
+          <p:cNvCxnSpPr/>
+          <p:nvPr/>
+        </p:nvCxnSpPr>
+        <p:spPr>
+          <a:xfrm>
+            <a:off x="2005200" y="1600200"/>
+            <a:ext cx="0" cy="360000"/>
+          </a:xfrm>
+          <a:prstGeom prst="line">
+            <a:avLst/>
+          </a:prstGeom>
+        </p:spPr>
+        <p:style>
+          <a:lnRef idx="1">
+            <a:schemeClr val="accent1"/>
+          </a:lnRef>
+          <a:fillRef idx="0">
+            <a:schemeClr val="accent1"/>
+          </a:fillRef>
+          <a:effectRef idx="0">
+            <a:schemeClr val="accent1"/>
+          </a:effectRef>
+          <a:fontRef idx="minor">
+            <a:schemeClr val="tx1"/>
+          </a:fontRef>
+        </p:style>
+      </p:cxnSp>
+      <p:cxnSp>
+        <p:nvCxnSpPr>
+          <p:cNvPr id="84" name="Straight Connector 83"/>
+          <p:cNvCxnSpPr/>
+          <p:nvPr/>
+        </p:nvCxnSpPr>
+        <p:spPr>
+          <a:xfrm>
+            <a:off x="2365200" y="1600200"/>
+            <a:ext cx="0" cy="360000"/>
+          </a:xfrm>
+          <a:prstGeom prst="line">
+            <a:avLst/>
+          </a:prstGeom>
+        </p:spPr>
+        <p:style>
+          <a:lnRef idx="1">
+            <a:schemeClr val="accent1"/>
+          </a:lnRef>
+          <a:fillRef idx="0">
+            <a:schemeClr val="accent1"/>
+          </a:fillRef>
+          <a:effectRef idx="0">
+            <a:schemeClr val="accent1"/>
+          </a:effectRef>
+          <a:fontRef idx="minor">
+            <a:schemeClr val="tx1"/>
+          </a:fontRef>
+        </p:style>
+      </p:cxnSp>
+      <p:cxnSp>
+        <p:nvCxnSpPr>
+          <p:cNvPr id="85" name="Straight Connector 84"/>
+          <p:cNvCxnSpPr/>
+          <p:nvPr/>
+        </p:nvCxnSpPr>
+        <p:spPr>
+          <a:xfrm>
+            <a:off x="2365200" y="1960200"/>
+            <a:ext cx="360000" cy="0"/>
+          </a:xfrm>
+          <a:prstGeom prst="line">
+            <a:avLst/>
+          </a:prstGeom>
+        </p:spPr>
+        <p:style>
+          <a:lnRef idx="1">
+            <a:schemeClr val="accent1"/>
+          </a:lnRef>
+          <a:fillRef idx="0">
+            <a:schemeClr val="accent1"/>
+          </a:fillRef>
+          <a:effectRef idx="0">
+            <a:schemeClr val="accent1"/>
+          </a:effectRef>
+          <a:fontRef idx="minor">
+            <a:schemeClr val="tx1"/>
+          </a:fontRef>
+        </p:style>
+      </p:cxnSp>
+      <p:cxnSp>
+        <p:nvCxnSpPr>
+          <p:cNvPr id="86" name="Straight Connector 85"/>
+          <p:cNvCxnSpPr/>
+          <p:nvPr/>
+        </p:nvCxnSpPr>
+        <p:spPr>
+          <a:xfrm>
+            <a:off x="2005200" y="3078000"/>
+            <a:ext cx="842400" cy="0"/>
+          </a:xfrm>
+          <a:prstGeom prst="line">
+            <a:avLst/>
+          </a:prstGeom>
+        </p:spPr>
+        <p:style>
+          <a:lnRef idx="1">
+            <a:schemeClr val="accent1"/>
+          </a:lnRef>
+          <a:fillRef idx="0">
+            <a:schemeClr val="accent1"/>
+          </a:fillRef>
+          <a:effectRef idx="0">
+            <a:schemeClr val="accent1"/>
+          </a:effectRef>
+          <a:fontRef idx="minor">
+            <a:schemeClr val="tx1"/>
+          </a:fontRef>
+        </p:style>
+      </p:cxnSp>
+      <p:cxnSp>
+        <p:nvCxnSpPr>
+          <p:cNvPr id="89" name="Straight Connector 88"/>
+          <p:cNvCxnSpPr/>
+          <p:nvPr/>
+        </p:nvCxnSpPr>
+        <p:spPr>
+          <a:xfrm>
+            <a:off x="2005200" y="2718000"/>
+            <a:ext cx="842400" cy="0"/>
+          </a:xfrm>
+          <a:prstGeom prst="line">
+            <a:avLst/>
+          </a:prstGeom>
+        </p:spPr>
+        <p:style>
+          <a:lnRef idx="1">
+            <a:schemeClr val="accent1"/>
+          </a:lnRef>
+          <a:fillRef idx="0">
+            <a:schemeClr val="accent1"/>
+          </a:fillRef>
+          <a:effectRef idx="0">
+            <a:schemeClr val="accent1"/>
+          </a:effectRef>
+          <a:fontRef idx="minor">
+            <a:schemeClr val="tx1"/>
+          </a:fontRef>
+        </p:style>
+      </p:cxnSp>
+      <p:sp>
+        <p:nvSpPr>
+          <p:cNvPr id="107" name="TextBox 106"/>
+          <p:cNvSpPr txBox="1"/>
+          <p:nvPr/>
+        </p:nvSpPr>
+        <p:spPr>
+          <a:xfrm>
+            <a:off x="1159590" y="2724150"/>
+            <a:ext cx="897810" cy="338554"/>
+          </a:xfrm>
+          <a:prstGeom prst="rect">
+            <a:avLst/>
+          </a:prstGeom>
+          <a:noFill/>
+        </p:spPr>
+        <p:txBody>
+          <a:bodyPr wrap="none" rtlCol="0">
+            <a:spAutoFit/>
+          </a:bodyPr>
+          <a:lstStyle/>
+          <a:p>
+            <a:r>
+              <a:rPr lang="en-GB" sz="1600" dirty="0" smtClean="0"/>
+              <a:t>OPCODE</a:t>
+            </a:r>
+            <a:endParaRPr lang="en-GB" sz="1600" dirty="0" smtClean="0"/>
+          </a:p>
+        </p:txBody>
+      </p:sp>
+      <p:cxnSp>
+        <p:nvCxnSpPr>
+          <p:cNvPr id="109" name="Straight Connector 108"/>
+          <p:cNvCxnSpPr/>
+          <p:nvPr/>
+        </p:nvCxnSpPr>
+        <p:spPr>
+          <a:xfrm>
+            <a:off x="2847600" y="2718000"/>
+            <a:ext cx="2037600" cy="0"/>
+          </a:xfrm>
+          <a:prstGeom prst="line">
+            <a:avLst/>
+          </a:prstGeom>
+        </p:spPr>
+        <p:style>
+          <a:lnRef idx="1">
+            <a:schemeClr val="accent1"/>
+          </a:lnRef>
+          <a:fillRef idx="0">
+            <a:schemeClr val="accent1"/>
+          </a:fillRef>
+          <a:effectRef idx="0">
+            <a:schemeClr val="accent1"/>
+          </a:effectRef>
+          <a:fontRef idx="minor">
+            <a:schemeClr val="tx1"/>
+          </a:fontRef>
+        </p:style>
+      </p:cxnSp>
+      <p:cxnSp>
+        <p:nvCxnSpPr>
+          <p:cNvPr id="110" name="Straight Connector 109"/>
+          <p:cNvCxnSpPr/>
+          <p:nvPr/>
+        </p:nvCxnSpPr>
+        <p:spPr>
+          <a:xfrm>
+            <a:off x="2847600" y="3078000"/>
+            <a:ext cx="2037600" cy="0"/>
+          </a:xfrm>
+          <a:prstGeom prst="line">
+            <a:avLst/>
+          </a:prstGeom>
+        </p:spPr>
+        <p:style>
+          <a:lnRef idx="1">
+            <a:schemeClr val="accent1"/>
+          </a:lnRef>
+          <a:fillRef idx="0">
+            <a:schemeClr val="accent1"/>
+          </a:fillRef>
+          <a:effectRef idx="0">
+            <a:schemeClr val="accent1"/>
+          </a:effectRef>
+          <a:fontRef idx="minor">
+            <a:schemeClr val="tx1"/>
+          </a:fontRef>
+        </p:style>
+      </p:cxnSp>
+      <p:sp>
+        <p:nvSpPr>
+          <p:cNvPr id="111" name="TextBox 110"/>
+          <p:cNvSpPr txBox="1"/>
+          <p:nvPr/>
+        </p:nvSpPr>
+        <p:spPr>
+          <a:xfrm>
+            <a:off x="2209800" y="2771001"/>
+            <a:ext cx="2463175" cy="276999"/>
+          </a:xfrm>
+          <a:prstGeom prst="rect">
+            <a:avLst/>
+          </a:prstGeom>
+          <a:noFill/>
+        </p:spPr>
+        <p:txBody>
+          <a:bodyPr wrap="none" rtlCol="0">
+            <a:spAutoFit/>
+          </a:bodyPr>
+          <a:lstStyle/>
+          <a:p>
+            <a:r>
+              <a:rPr lang="en-GB" sz="1200" dirty="0" smtClean="0"/>
+              <a:t>OPCODE From ROM Address 0x0000</a:t>
+            </a:r>
+            <a:endParaRPr lang="en-GB" sz="1200" dirty="0"/>
+          </a:p>
+        </p:txBody>
+      </p:sp>
+      <p:sp>
+        <p:nvSpPr>
+          <p:cNvPr id="112" name="TextBox 111"/>
+          <p:cNvSpPr txBox="1"/>
+          <p:nvPr/>
+        </p:nvSpPr>
+        <p:spPr>
+          <a:xfrm>
+            <a:off x="1555339" y="3276600"/>
+            <a:ext cx="502061" cy="338554"/>
+          </a:xfrm>
+          <a:prstGeom prst="rect">
+            <a:avLst/>
+          </a:prstGeom>
+          <a:noFill/>
+        </p:spPr>
+        <p:txBody>
+          <a:bodyPr wrap="none" rtlCol="0">
+            <a:spAutoFit/>
+          </a:bodyPr>
+          <a:lstStyle/>
+          <a:p>
+            <a:r>
+              <a:rPr lang="en-GB" sz="1600" dirty="0" smtClean="0"/>
+              <a:t>OLS</a:t>
+            </a:r>
+            <a:endParaRPr lang="en-GB" sz="1600" dirty="0"/>
+          </a:p>
+        </p:txBody>
+      </p:sp>
+      <p:cxnSp>
+        <p:nvCxnSpPr>
+          <p:cNvPr id="113" name="Straight Connector 112"/>
+          <p:cNvCxnSpPr/>
+          <p:nvPr/>
+        </p:nvCxnSpPr>
+        <p:spPr>
+          <a:xfrm>
+            <a:off x="2005200" y="3636000"/>
+            <a:ext cx="421200" cy="0"/>
+          </a:xfrm>
+          <a:prstGeom prst="line">
+            <a:avLst/>
+          </a:prstGeom>
+        </p:spPr>
+        <p:style>
+          <a:lnRef idx="1">
+            <a:schemeClr val="accent1"/>
+          </a:lnRef>
+          <a:fillRef idx="0">
+            <a:schemeClr val="accent1"/>
+          </a:fillRef>
+          <a:effectRef idx="0">
+            <a:schemeClr val="accent1"/>
+          </a:effectRef>
+          <a:fontRef idx="minor">
+            <a:schemeClr val="tx1"/>
+          </a:fontRef>
+        </p:style>
+      </p:cxnSp>
+      <p:cxnSp>
+        <p:nvCxnSpPr>
+          <p:cNvPr id="118" name="Straight Connector 117"/>
+          <p:cNvCxnSpPr/>
+          <p:nvPr/>
+        </p:nvCxnSpPr>
+        <p:spPr>
+          <a:xfrm>
+            <a:off x="3146400" y="3276000"/>
+            <a:ext cx="0" cy="360000"/>
+          </a:xfrm>
+          <a:prstGeom prst="line">
+            <a:avLst/>
+          </a:prstGeom>
+        </p:spPr>
+        <p:style>
+          <a:lnRef idx="1">
+            <a:schemeClr val="accent1"/>
+          </a:lnRef>
+          <a:fillRef idx="0">
+            <a:schemeClr val="accent1"/>
+          </a:fillRef>
+          <a:effectRef idx="0">
+            <a:schemeClr val="accent1"/>
+          </a:effectRef>
+          <a:fontRef idx="minor">
+            <a:schemeClr val="tx1"/>
+          </a:fontRef>
+        </p:style>
+      </p:cxnSp>
+      <p:cxnSp>
+        <p:nvCxnSpPr>
+          <p:cNvPr id="119" name="Straight Connector 118"/>
+          <p:cNvCxnSpPr/>
+          <p:nvPr/>
+        </p:nvCxnSpPr>
+        <p:spPr>
+          <a:xfrm>
+            <a:off x="3146400" y="3276000"/>
+            <a:ext cx="360000" cy="0"/>
+          </a:xfrm>
+          <a:prstGeom prst="line">
+            <a:avLst/>
+          </a:prstGeom>
+        </p:spPr>
+        <p:style>
+          <a:lnRef idx="1">
+            <a:schemeClr val="accent1"/>
+          </a:lnRef>
+          <a:fillRef idx="0">
+            <a:schemeClr val="accent1"/>
+          </a:fillRef>
+          <a:effectRef idx="0">
+            <a:schemeClr val="accent1"/>
+          </a:effectRef>
+          <a:fontRef idx="minor">
+            <a:schemeClr val="tx1"/>
+          </a:fontRef>
+        </p:style>
+      </p:cxnSp>
+      <p:cxnSp>
+        <p:nvCxnSpPr>
+          <p:cNvPr id="120" name="Straight Connector 119"/>
+          <p:cNvCxnSpPr/>
+          <p:nvPr/>
+        </p:nvCxnSpPr>
+        <p:spPr>
+          <a:xfrm>
+            <a:off x="3506400" y="3276000"/>
+            <a:ext cx="0" cy="360000"/>
+          </a:xfrm>
+          <a:prstGeom prst="line">
+            <a:avLst/>
+          </a:prstGeom>
+        </p:spPr>
+        <p:style>
+          <a:lnRef idx="1">
+            <a:schemeClr val="accent1"/>
+          </a:lnRef>
+          <a:fillRef idx="0">
+            <a:schemeClr val="accent1"/>
+          </a:fillRef>
+          <a:effectRef idx="0">
+            <a:schemeClr val="accent1"/>
+          </a:effectRef>
+          <a:fontRef idx="minor">
+            <a:schemeClr val="tx1"/>
+          </a:fontRef>
+        </p:style>
+      </p:cxnSp>
+      <p:cxnSp>
+        <p:nvCxnSpPr>
+          <p:cNvPr id="121" name="Straight Connector 120"/>
+          <p:cNvCxnSpPr/>
+          <p:nvPr/>
+        </p:nvCxnSpPr>
+        <p:spPr>
+          <a:xfrm>
+            <a:off x="3506400" y="3636000"/>
+            <a:ext cx="1378800" cy="0"/>
+          </a:xfrm>
+          <a:prstGeom prst="line">
+            <a:avLst/>
+          </a:prstGeom>
+        </p:spPr>
+        <p:style>
+          <a:lnRef idx="1">
+            <a:schemeClr val="accent1"/>
+          </a:lnRef>
+          <a:fillRef idx="0">
+            <a:schemeClr val="accent1"/>
+          </a:fillRef>
+          <a:effectRef idx="0">
+            <a:schemeClr val="accent1"/>
+          </a:effectRef>
+          <a:fontRef idx="minor">
+            <a:schemeClr val="tx1"/>
+          </a:fontRef>
+        </p:style>
+      </p:cxnSp>
+      <p:sp>
+        <p:nvSpPr>
+          <p:cNvPr id="60" name="TextBox 59"/>
+          <p:cNvSpPr txBox="1"/>
+          <p:nvPr/>
+        </p:nvSpPr>
+        <p:spPr>
+          <a:xfrm>
+            <a:off x="2597453" y="533400"/>
+            <a:ext cx="4090159" cy="369332"/>
+          </a:xfrm>
+          <a:prstGeom prst="rect">
+            <a:avLst/>
+          </a:prstGeom>
+          <a:noFill/>
+        </p:spPr>
+        <p:txBody>
+          <a:bodyPr wrap="none" rtlCol="0">
+            <a:spAutoFit/>
+          </a:bodyPr>
+          <a:lstStyle/>
+          <a:p>
+            <a:r>
+              <a:rPr lang="en-GB" dirty="0" smtClean="0"/>
+              <a:t>INITIAL SEQUENCE (AFTER RESET) TIMING</a:t>
+            </a:r>
+            <a:endParaRPr lang="en-GB" dirty="0"/>
+          </a:p>
+        </p:txBody>
+      </p:sp>
+      <p:cxnSp>
+        <p:nvCxnSpPr>
+          <p:cNvPr id="61" name="Straight Connector 60"/>
+          <p:cNvCxnSpPr/>
+          <p:nvPr/>
+        </p:nvCxnSpPr>
+        <p:spPr>
+          <a:xfrm>
+            <a:off x="2426400" y="3276000"/>
+            <a:ext cx="0" cy="360000"/>
+          </a:xfrm>
+          <a:prstGeom prst="line">
+            <a:avLst/>
+          </a:prstGeom>
+        </p:spPr>
+        <p:style>
+          <a:lnRef idx="1">
+            <a:schemeClr val="accent1"/>
+          </a:lnRef>
+          <a:fillRef idx="0">
+            <a:schemeClr val="accent1"/>
+          </a:fillRef>
+          <a:effectRef idx="0">
+            <a:schemeClr val="accent1"/>
+          </a:effectRef>
+          <a:fontRef idx="minor">
+            <a:schemeClr val="tx1"/>
+          </a:fontRef>
+        </p:style>
+      </p:cxnSp>
+      <p:cxnSp>
+        <p:nvCxnSpPr>
+          <p:cNvPr id="62" name="Straight Connector 61"/>
+          <p:cNvCxnSpPr/>
+          <p:nvPr/>
+        </p:nvCxnSpPr>
+        <p:spPr>
+          <a:xfrm>
+            <a:off x="2786400" y="3276000"/>
+            <a:ext cx="0" cy="360000"/>
+          </a:xfrm>
+          <a:prstGeom prst="line">
+            <a:avLst/>
+          </a:prstGeom>
+        </p:spPr>
+        <p:style>
+          <a:lnRef idx="1">
+            <a:schemeClr val="accent1"/>
+          </a:lnRef>
+          <a:fillRef idx="0">
+            <a:schemeClr val="accent1"/>
+          </a:fillRef>
+          <a:effectRef idx="0">
+            <a:schemeClr val="accent1"/>
+          </a:effectRef>
+          <a:fontRef idx="minor">
+            <a:schemeClr val="tx1"/>
+          </a:fontRef>
+        </p:style>
+      </p:cxnSp>
+      <p:cxnSp>
+        <p:nvCxnSpPr>
+          <p:cNvPr id="73" name="Straight Connector 72"/>
+          <p:cNvCxnSpPr/>
+          <p:nvPr/>
+        </p:nvCxnSpPr>
+        <p:spPr>
+          <a:xfrm>
+            <a:off x="2426400" y="3276000"/>
+            <a:ext cx="360000" cy="0"/>
+          </a:xfrm>
+          <a:prstGeom prst="line">
+            <a:avLst/>
+          </a:prstGeom>
+        </p:spPr>
+        <p:style>
+          <a:lnRef idx="1">
+            <a:schemeClr val="accent1"/>
+          </a:lnRef>
+          <a:fillRef idx="0">
+            <a:schemeClr val="accent1"/>
+          </a:fillRef>
+          <a:effectRef idx="0">
+            <a:schemeClr val="accent1"/>
+          </a:effectRef>
+          <a:fontRef idx="minor">
+            <a:schemeClr val="tx1"/>
+          </a:fontRef>
+        </p:style>
+      </p:cxnSp>
+      <p:cxnSp>
+        <p:nvCxnSpPr>
+          <p:cNvPr id="74" name="Straight Connector 73"/>
+          <p:cNvCxnSpPr/>
+          <p:nvPr/>
+        </p:nvCxnSpPr>
+        <p:spPr>
+          <a:xfrm>
+            <a:off x="2786400" y="3636000"/>
+            <a:ext cx="360000" cy="0"/>
+          </a:xfrm>
+          <a:prstGeom prst="line">
+            <a:avLst/>
+          </a:prstGeom>
+        </p:spPr>
+        <p:style>
+          <a:lnRef idx="1">
+            <a:schemeClr val="accent1"/>
+          </a:lnRef>
+          <a:fillRef idx="0">
+            <a:schemeClr val="accent1"/>
+          </a:fillRef>
+          <a:effectRef idx="0">
+            <a:schemeClr val="accent1"/>
+          </a:effectRef>
+          <a:fontRef idx="minor">
+            <a:schemeClr val="tx1"/>
+          </a:fontRef>
+        </p:style>
+      </p:cxnSp>
     </p:spTree>
   </p:cSld>
   <p:clrMapOvr>

</xml_diff>